<commit_message>
Add product catalogue: fixed prices, stock tracking, Products page
Co-Authored-By: Claude Opus 5.5 <noreply@anthropic.com>
</commit_message>
<xml_diff>
--- a/docs/presentation.pptx
+++ b/docs/presentation.pptx
@@ -17,6 +17,7 @@
     <p:sldId id="265" r:id="rId11"/>
     <p:sldId id="266" r:id="rId12"/>
     <p:sldId id="267" r:id="rId13"/>
+    <p:sldId id="272" r:id="rId23"/>
     <p:sldId id="268" r:id="rId14"/>
     <p:sldId id="269" r:id="rId15"/>
     <p:sldId id="270" r:id="rId16"/>
@@ -209,35 +210,33 @@
             <c:showLeaderLines val="0"/>
           </c:dLbls>
           <c:cat>
-            <c:multiLvlStrRef>
+            <c:strRef>
               <c:f>Sheet1!$A$2:$A$8</c:f>
-              <c:multiLvlStrCache>
+              <c:strCache>
                 <c:ptCount val="7"/>
-                <c:lvl>
-                  <c:pt idx="0">
-                    <c:v>Electronics</c:v>
-                  </c:pt>
-                  <c:pt idx="1">
-                    <c:v>Home &amp; Kitchen</c:v>
-                  </c:pt>
-                  <c:pt idx="2">
-                    <c:v>Fashion</c:v>
-                  </c:pt>
-                  <c:pt idx="3">
-                    <c:v>Sports</c:v>
-                  </c:pt>
-                  <c:pt idx="4">
-                    <c:v>Beauty</c:v>
-                  </c:pt>
-                  <c:pt idx="5">
-                    <c:v>Toys</c:v>
-                  </c:pt>
-                  <c:pt idx="6">
-                    <c:v>Books</c:v>
-                  </c:pt>
-                </c:lvl>
-              </c:multiLvlStrCache>
-            </c:multiLvlStrRef>
+                <c:pt idx="0">
+                  <c:v>Electronics</c:v>
+                </c:pt>
+                <c:pt idx="1">
+                  <c:v>Home &amp; Kitchen</c:v>
+                </c:pt>
+                <c:pt idx="2">
+                  <c:v>Fashion</c:v>
+                </c:pt>
+                <c:pt idx="3">
+                  <c:v>Sports</c:v>
+                </c:pt>
+                <c:pt idx="4">
+                  <c:v>Beauty</c:v>
+                </c:pt>
+                <c:pt idx="5">
+                  <c:v>Toys</c:v>
+                </c:pt>
+                <c:pt idx="6">
+                  <c:v>Books</c:v>
+                </c:pt>
+              </c:strCache>
+            </c:strRef>
           </c:cat>
           <c:val>
             <c:numRef>
@@ -246,25 +245,25 @@
                 <c:formatCode>General</c:formatCode>
                 <c:ptCount val="7"/>
                 <c:pt idx="0">
-                  <c:v>122.2</c:v>
+                  <c:v>69.9</c:v>
                 </c:pt>
                 <c:pt idx="1">
-                  <c:v>32.6</c:v>
+                  <c:v>26.2</c:v>
                 </c:pt>
                 <c:pt idx="2">
-                  <c:v>27.9</c:v>
+                  <c:v>18.7</c:v>
                 </c:pt>
                 <c:pt idx="3">
-                  <c:v>18.5</c:v>
+                  <c:v>13.2</c:v>
                 </c:pt>
                 <c:pt idx="4">
-                  <c:v>12.5</c:v>
+                  <c:v>9.9</c:v>
                 </c:pt>
                 <c:pt idx="5">
-                  <c:v>8.6</c:v>
+                  <c:v>5.7</c:v>
                 </c:pt>
                 <c:pt idx="6">
-                  <c:v>4.8</c:v>
+                  <c:v>5.2</c:v>
                 </c:pt>
               </c:numCache>
             </c:numRef>
@@ -502,23 +501,21 @@
             <c:showLeaderLines val="0"/>
           </c:dLbls>
           <c:cat>
-            <c:multiLvlStrRef>
+            <c:strRef>
               <c:f>Sheet1!$A$2:$A$4</c:f>
-              <c:multiLvlStrCache>
+              <c:strCache>
                 <c:ptCount val="3"/>
-                <c:lvl>
-                  <c:pt idx="0">
-                    <c:v>New</c:v>
-                  </c:pt>
-                  <c:pt idx="1">
-                    <c:v>Regular</c:v>
-                  </c:pt>
-                  <c:pt idx="2">
-                    <c:v>VIP</c:v>
-                  </c:pt>
-                </c:lvl>
-              </c:multiLvlStrCache>
-            </c:multiLvlStrRef>
+                <c:pt idx="0">
+                  <c:v>New</c:v>
+                </c:pt>
+                <c:pt idx="1">
+                  <c:v>Regular</c:v>
+                </c:pt>
+                <c:pt idx="2">
+                  <c:v>VIP</c:v>
+                </c:pt>
+              </c:strCache>
+            </c:strRef>
           </c:cat>
           <c:val>
             <c:numRef>
@@ -527,13 +524,13 @@
                 <c:formatCode>General</c:formatCode>
                 <c:ptCount val="3"/>
                 <c:pt idx="0">
-                  <c:v>1.62</c:v>
+                  <c:v>1.63</c:v>
                 </c:pt>
                 <c:pt idx="1">
-                  <c:v>2.45</c:v>
+                  <c:v>2.47</c:v>
                 </c:pt>
                 <c:pt idx="2">
-                  <c:v>4.83</c:v>
+                  <c:v>4.89</c:v>
                 </c:pt>
               </c:numCache>
             </c:numRef>
@@ -771,23 +768,21 @@
             <c:showLeaderLines val="0"/>
           </c:dLbls>
           <c:cat>
-            <c:multiLvlStrRef>
+            <c:strRef>
               <c:f>Sheet1!$A$2:$A$4</c:f>
-              <c:multiLvlStrCache>
+              <c:strCache>
                 <c:ptCount val="3"/>
-                <c:lvl>
-                  <c:pt idx="0">
-                    <c:v>New</c:v>
-                  </c:pt>
-                  <c:pt idx="1">
-                    <c:v>Regular</c:v>
-                  </c:pt>
-                  <c:pt idx="2">
-                    <c:v>VIP</c:v>
-                  </c:pt>
-                </c:lvl>
-              </c:multiLvlStrCache>
-            </c:multiLvlStrRef>
+                <c:pt idx="0">
+                  <c:v>New</c:v>
+                </c:pt>
+                <c:pt idx="1">
+                  <c:v>Regular</c:v>
+                </c:pt>
+                <c:pt idx="2">
+                  <c:v>VIP</c:v>
+                </c:pt>
+              </c:strCache>
+            </c:strRef>
           </c:cat>
           <c:val>
             <c:numRef>
@@ -796,13 +791,13 @@
                 <c:formatCode>General</c:formatCode>
                 <c:ptCount val="3"/>
                 <c:pt idx="0">
-                  <c:v>137.2</c:v>
+                  <c:v>97.3</c:v>
                 </c:pt>
                 <c:pt idx="1">
-                  <c:v>138.4</c:v>
+                  <c:v>94.6</c:v>
                 </c:pt>
                 <c:pt idx="2">
-                  <c:v>131.6</c:v>
+                  <c:v>86.7</c:v>
                 </c:pt>
               </c:numCache>
             </c:numRef>
@@ -1041,23 +1036,21 @@
             <c:showLeaderLines val="0"/>
           </c:dLbls>
           <c:cat>
-            <c:multiLvlStrRef>
+            <c:strRef>
               <c:f>Sheet1!$A$2:$A$4</c:f>
-              <c:multiLvlStrCache>
+              <c:strCache>
                 <c:ptCount val="3"/>
-                <c:lvl>
-                  <c:pt idx="0">
-                    <c:v>New</c:v>
-                  </c:pt>
-                  <c:pt idx="1">
-                    <c:v>Regular</c:v>
-                  </c:pt>
-                  <c:pt idx="2">
-                    <c:v>VIP</c:v>
-                  </c:pt>
-                </c:lvl>
-              </c:multiLvlStrCache>
-            </c:multiLvlStrRef>
+                <c:pt idx="0">
+                  <c:v>New</c:v>
+                </c:pt>
+                <c:pt idx="1">
+                  <c:v>Regular</c:v>
+                </c:pt>
+                <c:pt idx="2">
+                  <c:v>VIP</c:v>
+                </c:pt>
+              </c:strCache>
+            </c:strRef>
           </c:cat>
           <c:val>
             <c:numRef>
@@ -1066,13 +1059,13 @@
                 <c:formatCode>General</c:formatCode>
                 <c:ptCount val="3"/>
                 <c:pt idx="0">
-                  <c:v>185</c:v>
+                  <c:v>124</c:v>
                 </c:pt>
                 <c:pt idx="1">
-                  <c:v>291</c:v>
+                  <c:v>188</c:v>
                 </c:pt>
                 <c:pt idx="2">
-                  <c:v>539</c:v>
+                  <c:v>353</c:v>
                 </c:pt>
               </c:numCache>
             </c:numRef>
@@ -1310,68 +1303,66 @@
             <c:showLeaderLines val="0"/>
           </c:dLbls>
           <c:cat>
-            <c:multiLvlStrRef>
+            <c:strRef>
               <c:f>Sheet1!$A$2:$A$19</c:f>
-              <c:multiLvlStrCache>
+              <c:strCache>
                 <c:ptCount val="18"/>
-                <c:lvl>
-                  <c:pt idx="0">
-                    <c:v>Jan-24</c:v>
-                  </c:pt>
-                  <c:pt idx="1">
-                    <c:v>Feb</c:v>
-                  </c:pt>
-                  <c:pt idx="2">
-                    <c:v>Mar</c:v>
-                  </c:pt>
-                  <c:pt idx="3">
-                    <c:v>Apr</c:v>
-                  </c:pt>
-                  <c:pt idx="4">
-                    <c:v>May</c:v>
-                  </c:pt>
-                  <c:pt idx="5">
-                    <c:v>Jun</c:v>
-                  </c:pt>
-                  <c:pt idx="6">
-                    <c:v>Jul</c:v>
-                  </c:pt>
-                  <c:pt idx="7">
-                    <c:v>Aug</c:v>
-                  </c:pt>
-                  <c:pt idx="8">
-                    <c:v>Sep</c:v>
-                  </c:pt>
-                  <c:pt idx="9">
-                    <c:v>Oct</c:v>
-                  </c:pt>
-                  <c:pt idx="10">
-                    <c:v>Nov</c:v>
-                  </c:pt>
-                  <c:pt idx="11">
-                    <c:v>Dec</c:v>
-                  </c:pt>
-                  <c:pt idx="12">
-                    <c:v>Jan-25</c:v>
-                  </c:pt>
-                  <c:pt idx="13">
-                    <c:v>Feb</c:v>
-                  </c:pt>
-                  <c:pt idx="14">
-                    <c:v>Mar</c:v>
-                  </c:pt>
-                  <c:pt idx="15">
-                    <c:v>Apr</c:v>
-                  </c:pt>
-                  <c:pt idx="16">
-                    <c:v>May</c:v>
-                  </c:pt>
-                  <c:pt idx="17">
-                    <c:v>Jun</c:v>
-                  </c:pt>
-                </c:lvl>
-              </c:multiLvlStrCache>
-            </c:multiLvlStrRef>
+                <c:pt idx="0">
+                  <c:v>Jan-24</c:v>
+                </c:pt>
+                <c:pt idx="1">
+                  <c:v>Feb</c:v>
+                </c:pt>
+                <c:pt idx="2">
+                  <c:v>Mar</c:v>
+                </c:pt>
+                <c:pt idx="3">
+                  <c:v>Apr</c:v>
+                </c:pt>
+                <c:pt idx="4">
+                  <c:v>May</c:v>
+                </c:pt>
+                <c:pt idx="5">
+                  <c:v>Jun</c:v>
+                </c:pt>
+                <c:pt idx="6">
+                  <c:v>Jul</c:v>
+                </c:pt>
+                <c:pt idx="7">
+                  <c:v>Aug</c:v>
+                </c:pt>
+                <c:pt idx="8">
+                  <c:v>Sep</c:v>
+                </c:pt>
+                <c:pt idx="9">
+                  <c:v>Oct</c:v>
+                </c:pt>
+                <c:pt idx="10">
+                  <c:v>Nov</c:v>
+                </c:pt>
+                <c:pt idx="11">
+                  <c:v>Dec</c:v>
+                </c:pt>
+                <c:pt idx="12">
+                  <c:v>Jan-25</c:v>
+                </c:pt>
+                <c:pt idx="13">
+                  <c:v>Feb</c:v>
+                </c:pt>
+                <c:pt idx="14">
+                  <c:v>Mar</c:v>
+                </c:pt>
+                <c:pt idx="15">
+                  <c:v>Apr</c:v>
+                </c:pt>
+                <c:pt idx="16">
+                  <c:v>May</c:v>
+                </c:pt>
+                <c:pt idx="17">
+                  <c:v>Jun</c:v>
+                </c:pt>
+              </c:strCache>
+            </c:strRef>
           </c:cat>
           <c:val>
             <c:numRef>
@@ -1380,40 +1371,40 @@
                 <c:formatCode>General</c:formatCode>
                 <c:ptCount val="18"/>
                 <c:pt idx="0">
-                  <c:v>75</c:v>
+                  <c:v>77</c:v>
                 </c:pt>
                 <c:pt idx="1">
-                  <c:v>66</c:v>
+                  <c:v>67</c:v>
                 </c:pt>
                 <c:pt idx="2">
-                  <c:v>75</c:v>
+                  <c:v>76</c:v>
                 </c:pt>
                 <c:pt idx="3">
-                  <c:v>101</c:v>
+                  <c:v>102</c:v>
                 </c:pt>
                 <c:pt idx="4">
-                  <c:v>125</c:v>
+                  <c:v>126</c:v>
                 </c:pt>
                 <c:pt idx="5">
-                  <c:v>113</c:v>
+                  <c:v>114</c:v>
                 </c:pt>
                 <c:pt idx="6">
-                  <c:v>110</c:v>
+                  <c:v>111</c:v>
                 </c:pt>
                 <c:pt idx="7">
-                  <c:v>137</c:v>
+                  <c:v>138</c:v>
                 </c:pt>
                 <c:pt idx="8">
-                  <c:v>119</c:v>
+                  <c:v>120</c:v>
                 </c:pt>
                 <c:pt idx="9">
-                  <c:v>103</c:v>
+                  <c:v>105</c:v>
                 </c:pt>
                 <c:pt idx="10">
-                  <c:v>172</c:v>
+                  <c:v>174</c:v>
                 </c:pt>
                 <c:pt idx="11">
-                  <c:v>183</c:v>
+                  <c:v>184</c:v>
                 </c:pt>
                 <c:pt idx="12">
                   <c:v>96</c:v>
@@ -1422,16 +1413,16 @@
                   <c:v>77</c:v>
                 </c:pt>
                 <c:pt idx="14">
-                  <c:v>95</c:v>
+                  <c:v>96</c:v>
                 </c:pt>
                 <c:pt idx="15">
-                  <c:v>93</c:v>
+                  <c:v>96</c:v>
                 </c:pt>
                 <c:pt idx="16">
-                  <c:v>109</c:v>
+                  <c:v>112</c:v>
                 </c:pt>
                 <c:pt idx="17">
-                  <c:v>123</c:v>
+                  <c:v>124</c:v>
                 </c:pt>
               </c:numCache>
             </c:numRef>
@@ -1539,68 +1530,66 @@
             </c:spPr>
           </c:marker>
           <c:cat>
-            <c:multiLvlStrRef>
+            <c:strRef>
               <c:f>Sheet1!$A$2:$A$19</c:f>
-              <c:multiLvlStrCache>
+              <c:strCache>
                 <c:ptCount val="18"/>
-                <c:lvl>
-                  <c:pt idx="0">
-                    <c:v>Jan-24</c:v>
-                  </c:pt>
-                  <c:pt idx="1">
-                    <c:v>Feb</c:v>
-                  </c:pt>
-                  <c:pt idx="2">
-                    <c:v>Mar</c:v>
-                  </c:pt>
-                  <c:pt idx="3">
-                    <c:v>Apr</c:v>
-                  </c:pt>
-                  <c:pt idx="4">
-                    <c:v>May</c:v>
-                  </c:pt>
-                  <c:pt idx="5">
-                    <c:v>Jun</c:v>
-                  </c:pt>
-                  <c:pt idx="6">
-                    <c:v>Jul</c:v>
-                  </c:pt>
-                  <c:pt idx="7">
-                    <c:v>Aug</c:v>
-                  </c:pt>
-                  <c:pt idx="8">
-                    <c:v>Sep</c:v>
-                  </c:pt>
-                  <c:pt idx="9">
-                    <c:v>Oct</c:v>
-                  </c:pt>
-                  <c:pt idx="10">
-                    <c:v>Nov</c:v>
-                  </c:pt>
-                  <c:pt idx="11">
-                    <c:v>Dec</c:v>
-                  </c:pt>
-                  <c:pt idx="12">
-                    <c:v>Jan-25</c:v>
-                  </c:pt>
-                  <c:pt idx="13">
-                    <c:v>Feb</c:v>
-                  </c:pt>
-                  <c:pt idx="14">
-                    <c:v>Mar</c:v>
-                  </c:pt>
-                  <c:pt idx="15">
-                    <c:v>Apr</c:v>
-                  </c:pt>
-                  <c:pt idx="16">
-                    <c:v>May</c:v>
-                  </c:pt>
-                  <c:pt idx="17">
-                    <c:v>Jun</c:v>
-                  </c:pt>
-                </c:lvl>
-              </c:multiLvlStrCache>
-            </c:multiLvlStrRef>
+                <c:pt idx="0">
+                  <c:v>Jan-24</c:v>
+                </c:pt>
+                <c:pt idx="1">
+                  <c:v>Feb</c:v>
+                </c:pt>
+                <c:pt idx="2">
+                  <c:v>Mar</c:v>
+                </c:pt>
+                <c:pt idx="3">
+                  <c:v>Apr</c:v>
+                </c:pt>
+                <c:pt idx="4">
+                  <c:v>May</c:v>
+                </c:pt>
+                <c:pt idx="5">
+                  <c:v>Jun</c:v>
+                </c:pt>
+                <c:pt idx="6">
+                  <c:v>Jul</c:v>
+                </c:pt>
+                <c:pt idx="7">
+                  <c:v>Aug</c:v>
+                </c:pt>
+                <c:pt idx="8">
+                  <c:v>Sep</c:v>
+                </c:pt>
+                <c:pt idx="9">
+                  <c:v>Oct</c:v>
+                </c:pt>
+                <c:pt idx="10">
+                  <c:v>Nov</c:v>
+                </c:pt>
+                <c:pt idx="11">
+                  <c:v>Dec</c:v>
+                </c:pt>
+                <c:pt idx="12">
+                  <c:v>Jan-25</c:v>
+                </c:pt>
+                <c:pt idx="13">
+                  <c:v>Feb</c:v>
+                </c:pt>
+                <c:pt idx="14">
+                  <c:v>Mar</c:v>
+                </c:pt>
+                <c:pt idx="15">
+                  <c:v>Apr</c:v>
+                </c:pt>
+                <c:pt idx="16">
+                  <c:v>May</c:v>
+                </c:pt>
+                <c:pt idx="17">
+                  <c:v>Jun</c:v>
+                </c:pt>
+              </c:strCache>
+            </c:strRef>
           </c:cat>
           <c:val>
             <c:numRef>
@@ -1609,58 +1598,58 @@
                 <c:formatCode>General</c:formatCode>
                 <c:ptCount val="18"/>
                 <c:pt idx="0">
-                  <c:v>7.4</c:v>
+                  <c:v>5.7</c:v>
                 </c:pt>
                 <c:pt idx="1">
-                  <c:v>7</c:v>
+                  <c:v>5.1</c:v>
                 </c:pt>
                 <c:pt idx="2">
-                  <c:v>8.1</c:v>
+                  <c:v>5.5</c:v>
                 </c:pt>
                 <c:pt idx="3">
-                  <c:v>13.6</c:v>
+                  <c:v>7.1</c:v>
                 </c:pt>
                 <c:pt idx="4">
-                  <c:v>13.6</c:v>
+                  <c:v>9.8</c:v>
                 </c:pt>
                 <c:pt idx="5">
-                  <c:v>15.3</c:v>
+                  <c:v>11.5</c:v>
                 </c:pt>
                 <c:pt idx="6">
-                  <c:v>12.1</c:v>
+                  <c:v>8.0</c:v>
                 </c:pt>
                 <c:pt idx="7">
-                  <c:v>12.4</c:v>
+                  <c:v>8.0</c:v>
                 </c:pt>
                 <c:pt idx="8">
-                  <c:v>16.1</c:v>
+                  <c:v>8.8</c:v>
                 </c:pt>
                 <c:pt idx="9">
-                  <c:v>13.7</c:v>
+                  <c:v>6.8</c:v>
                 </c:pt>
                 <c:pt idx="10">
-                  <c:v>18.9</c:v>
+                  <c:v>10.5</c:v>
                 </c:pt>
                 <c:pt idx="11">
-                  <c:v>28.2</c:v>
+                  <c:v>13.3</c:v>
                 </c:pt>
                 <c:pt idx="12">
-                  <c:v>10.5</c:v>
+                  <c:v>7.3</c:v>
                 </c:pt>
                 <c:pt idx="13">
-                  <c:v>8.3</c:v>
+                  <c:v>4.4</c:v>
                 </c:pt>
                 <c:pt idx="14">
-                  <c:v>11</c:v>
+                  <c:v>9.6</c:v>
                 </c:pt>
                 <c:pt idx="15">
-                  <c:v>8.3</c:v>
+                  <c:v>7.9</c:v>
                 </c:pt>
                 <c:pt idx="16">
-                  <c:v>12.4</c:v>
+                  <c:v>9.4</c:v>
                 </c:pt>
                 <c:pt idx="17">
-                  <c:v>10.4</c:v>
+                  <c:v>9.9</c:v>
                 </c:pt>
               </c:numCache>
             </c:numRef>
@@ -2097,26 +2086,24 @@
             </c:spPr>
           </c:dPt>
           <c:cat>
-            <c:multiLvlStrRef>
+            <c:strRef>
               <c:f>Sheet1!$A$2:$A$5</c:f>
-              <c:multiLvlStrCache>
+              <c:strCache>
                 <c:ptCount val="4"/>
-                <c:lvl>
-                  <c:pt idx="0">
-                    <c:v>1–3 days</c:v>
-                  </c:pt>
-                  <c:pt idx="1">
-                    <c:v>4–6 days</c:v>
-                  </c:pt>
-                  <c:pt idx="2">
-                    <c:v>7–9 days</c:v>
-                  </c:pt>
-                  <c:pt idx="3">
-                    <c:v>10+ days</c:v>
-                  </c:pt>
-                </c:lvl>
-              </c:multiLvlStrCache>
-            </c:multiLvlStrRef>
+                <c:pt idx="0">
+                  <c:v>1–3 days</c:v>
+                </c:pt>
+                <c:pt idx="1">
+                  <c:v>4–6 days</c:v>
+                </c:pt>
+                <c:pt idx="2">
+                  <c:v>7–9 days</c:v>
+                </c:pt>
+                <c:pt idx="3">
+                  <c:v>10+ days</c:v>
+                </c:pt>
+              </c:strCache>
+            </c:strRef>
           </c:cat>
           <c:val>
             <c:numRef>
@@ -2125,16 +2112,16 @@
                 <c:formatCode>General</c:formatCode>
                 <c:ptCount val="4"/>
                 <c:pt idx="0">
-                  <c:v>3.96</c:v>
+                  <c:v>3.97</c:v>
                 </c:pt>
                 <c:pt idx="1">
-                  <c:v>3.65</c:v>
+                  <c:v>3.68</c:v>
                 </c:pt>
                 <c:pt idx="2">
-                  <c:v>3.34</c:v>
+                  <c:v>3.29</c:v>
                 </c:pt>
                 <c:pt idx="3">
-                  <c:v>3.02</c:v>
+                  <c:v>3.0</c:v>
                 </c:pt>
               </c:numCache>
             </c:numRef>
@@ -2374,35 +2361,33 @@
             <c:showLeaderLines val="0"/>
           </c:dLbls>
           <c:cat>
-            <c:multiLvlStrRef>
+            <c:strRef>
               <c:f>Sheet1!$A$2:$A$8</c:f>
-              <c:multiLvlStrCache>
+              <c:strCache>
                 <c:ptCount val="7"/>
-                <c:lvl>
-                  <c:pt idx="0">
-                    <c:v>Cambodia</c:v>
-                  </c:pt>
-                  <c:pt idx="1">
-                    <c:v>Thailand</c:v>
-                  </c:pt>
-                  <c:pt idx="2">
-                    <c:v>Vietnam</c:v>
-                  </c:pt>
-                  <c:pt idx="3">
-                    <c:v>Singapore</c:v>
-                  </c:pt>
-                  <c:pt idx="4">
-                    <c:v>Malaysia</c:v>
-                  </c:pt>
-                  <c:pt idx="5">
-                    <c:v>Philippines</c:v>
-                  </c:pt>
-                  <c:pt idx="6">
-                    <c:v>Indonesia</c:v>
-                  </c:pt>
-                </c:lvl>
-              </c:multiLvlStrCache>
-            </c:multiLvlStrRef>
+                <c:pt idx="0">
+                  <c:v>Cambodia</c:v>
+                </c:pt>
+                <c:pt idx="1">
+                  <c:v>Vietnam</c:v>
+                </c:pt>
+                <c:pt idx="2">
+                  <c:v>Thailand</c:v>
+                </c:pt>
+                <c:pt idx="3">
+                  <c:v>Singapore</c:v>
+                </c:pt>
+                <c:pt idx="4">
+                  <c:v>Philippines</c:v>
+                </c:pt>
+                <c:pt idx="5">
+                  <c:v>Malaysia</c:v>
+                </c:pt>
+                <c:pt idx="6">
+                  <c:v>Indonesia</c:v>
+                </c:pt>
+              </c:strCache>
+            </c:strRef>
           </c:cat>
           <c:val>
             <c:numRef>
@@ -2411,25 +2396,25 @@
                 <c:formatCode>General</c:formatCode>
                 <c:ptCount val="7"/>
                 <c:pt idx="0">
-                  <c:v>78.5</c:v>
+                  <c:v>47.5</c:v>
                 </c:pt>
                 <c:pt idx="1">
-                  <c:v>44.5</c:v>
+                  <c:v>28.3</c:v>
                 </c:pt>
                 <c:pt idx="2">
-                  <c:v>37.3</c:v>
+                  <c:v>27.6</c:v>
                 </c:pt>
                 <c:pt idx="3">
-                  <c:v>23.7</c:v>
+                  <c:v>14.6</c:v>
                 </c:pt>
                 <c:pt idx="4">
-                  <c:v>17.1</c:v>
+                  <c:v>12.8</c:v>
                 </c:pt>
                 <c:pt idx="5">
-                  <c:v>14.1</c:v>
+                  <c:v>10.1</c:v>
                 </c:pt>
                 <c:pt idx="6">
-                  <c:v>11.9</c:v>
+                  <c:v>7.8</c:v>
                 </c:pt>
               </c:numCache>
             </c:numRef>
@@ -2722,29 +2707,27 @@
             </c:spPr>
           </c:dPt>
           <c:cat>
-            <c:multiLvlStrRef>
+            <c:strRef>
               <c:f>Sheet1!$A$2:$A$6</c:f>
-              <c:multiLvlStrCache>
+              <c:strCache>
                 <c:ptCount val="5"/>
-                <c:lvl>
-                  <c:pt idx="0">
-                    <c:v>Social Media</c:v>
-                  </c:pt>
-                  <c:pt idx="1">
-                    <c:v>Email</c:v>
-                  </c:pt>
-                  <c:pt idx="2">
-                    <c:v>Paid Ads</c:v>
-                  </c:pt>
-                  <c:pt idx="3">
-                    <c:v>Organic Search</c:v>
-                  </c:pt>
-                  <c:pt idx="4">
-                    <c:v>Referral</c:v>
-                  </c:pt>
-                </c:lvl>
-              </c:multiLvlStrCache>
-            </c:multiLvlStrRef>
+                <c:pt idx="0">
+                  <c:v>Email</c:v>
+                </c:pt>
+                <c:pt idx="1">
+                  <c:v>Organic Search</c:v>
+                </c:pt>
+                <c:pt idx="2">
+                  <c:v>Paid Ads</c:v>
+                </c:pt>
+                <c:pt idx="3">
+                  <c:v>Social Media</c:v>
+                </c:pt>
+                <c:pt idx="4">
+                  <c:v>Referral</c:v>
+                </c:pt>
+              </c:strCache>
+            </c:strRef>
           </c:cat>
           <c:val>
             <c:numRef>
@@ -2753,19 +2736,19 @@
                 <c:formatCode>General</c:formatCode>
                 <c:ptCount val="5"/>
                 <c:pt idx="0">
-                  <c:v>333</c:v>
+                  <c:v>246</c:v>
                 </c:pt>
                 <c:pt idx="1">
-                  <c:v>325</c:v>
+                  <c:v>217</c:v>
                 </c:pt>
                 <c:pt idx="2">
-                  <c:v>322</c:v>
+                  <c:v>207</c:v>
                 </c:pt>
                 <c:pt idx="3">
-                  <c:v>314</c:v>
+                  <c:v>191</c:v>
                 </c:pt>
                 <c:pt idx="4">
-                  <c:v>237</c:v>
+                  <c:v>145</c:v>
                 </c:pt>
               </c:numCache>
             </c:numRef>
@@ -5028,6 +5011,10 @@
             <a:prstDash val="solid"/>
           </a:ln>
         </p:spPr>
+        <p:txBody>
+          <a:bodyPr/>
+          <a:p/>
+        </p:txBody>
       </p:sp>
       <p:sp>
         <p:nvSpPr>
@@ -5057,6 +5044,10 @@
             <a:prstDash val="solid"/>
           </a:ln>
         </p:spPr>
+        <p:txBody>
+          <a:bodyPr/>
+          <a:p/>
+        </p:txBody>
       </p:sp>
       <p:sp>
         <p:nvSpPr>
@@ -5169,7 +5160,7 @@
                 <a:ea typeface="Calibri" pitchFamily="34" charset="-122"/>
                 <a:cs typeface="Calibri" pitchFamily="34" charset="-120"/>
               </a:rPr>
-              <a:t>Sak  ·  September 2026</a:t>
+              <a:t>Sak  ·  October 2026</a:t>
             </a:r>
             <a:endParaRPr lang="en-US" sz="1600" dirty="0"/>
           </a:p>
@@ -5373,7 +5364,7 @@
                 <a:ea typeface="Cambria" pitchFamily="34" charset="-122"/>
                 <a:cs typeface="Cambria" pitchFamily="34" charset="-120"/>
               </a:rPr>
-              <a:t>$28.2k</a:t>
+              <a:t>$13.3k</a:t>
             </a:r>
             <a:endParaRPr lang="en-US" sz="4000" dirty="0"/>
           </a:p>
@@ -5451,7 +5442,7 @@
                 <a:ea typeface="Cambria" pitchFamily="34" charset="-122"/>
                 <a:cs typeface="Cambria" pitchFamily="34" charset="-120"/>
               </a:rPr>
-              <a:t>−63 %</a:t>
+              <a:t>−45 %</a:t>
             </a:r>
             <a:endParaRPr lang="en-US" sz="4000" dirty="0"/>
           </a:p>
@@ -5522,6 +5513,10 @@
             <a:prstDash val="solid"/>
           </a:ln>
         </p:spPr>
+        <p:txBody>
+          <a:bodyPr/>
+          <a:p/>
+        </p:txBody>
       </p:sp>
       <p:sp>
         <p:nvSpPr>
@@ -5570,7 +5565,7 @@
                 <a:ea typeface="Calibri" pitchFamily="34" charset="-122"/>
                 <a:cs typeface="Calibri" pitchFamily="34" charset="-120"/>
               </a:rPr>
-              <a:t>Nov–Dec is the peak season (mainly Electronics). H1 2025 runs slightly above H1 2024, so there is modest growth under the seasonality. Plan stock and ads for Q4; promote in January.</a:t>
+              <a:t>Nov–Dec is the peak season (mainly Electronics). H1 2025 runs above H1 2024, so there is modest growth under the seasonality. Plan stock and ads for Q4; promote in January.</a:t>
             </a:r>
             <a:endParaRPr lang="en-US" sz="1250" dirty="0"/>
           </a:p>
@@ -5641,7 +5636,7 @@
                 <a:ea typeface="Cambria" pitchFamily="34" charset="-122"/>
                 <a:cs typeface="Cambria" pitchFamily="34" charset="-120"/>
               </a:rPr>
-              <a:t>Q5 · Every extra delivery day costs ~0.1 star</a:t>
+              <a:t>Q5 · Every extra delivery day costs ~0.12 star</a:t>
             </a:r>
             <a:endParaRPr lang="en-US" sz="3200" dirty="0"/>
           </a:p>
@@ -5759,7 +5754,7 @@
                 <a:ea typeface="Cambria" pitchFamily="34" charset="-122"/>
                 <a:cs typeface="Cambria" pitchFamily="34" charset="-120"/>
               </a:rPr>
-              <a:t>r = −0.38</a:t>
+              <a:t>r = −0.41</a:t>
             </a:r>
             <a:endParaRPr lang="en-US" sz="4000" dirty="0"/>
           </a:p>
@@ -5798,7 +5793,7 @@
                 <a:ea typeface="Calibri" pitchFamily="34" charset="-122"/>
                 <a:cs typeface="Calibri" pitchFamily="34" charset="-120"/>
               </a:rPr>
-              <a:t>Pearson, p &lt; 0.001 (n = 1,223 reviews)</a:t>
+              <a:t>Pearson, p &lt; 0.001 (n = 1,247 reviews)</a:t>
             </a:r>
             <a:endParaRPr lang="en-US" sz="1200" dirty="0"/>
           </a:p>
@@ -5837,7 +5832,7 @@
                 <a:ea typeface="Cambria" pitchFamily="34" charset="-122"/>
                 <a:cs typeface="Cambria" pitchFamily="34" charset="-120"/>
               </a:rPr>
-              <a:t>F = 63.8</a:t>
+              <a:t>F = 75.0</a:t>
             </a:r>
             <a:endParaRPr lang="en-US" sz="4000" dirty="0"/>
           </a:p>
@@ -5908,6 +5903,10 @@
             <a:prstDash val="solid"/>
           </a:ln>
         </p:spPr>
+        <p:txBody>
+          <a:bodyPr/>
+          <a:p/>
+        </p:txBody>
       </p:sp>
       <p:sp>
         <p:nvSpPr>
@@ -5956,7 +5955,7 @@
                 <a:ea typeface="Calibri" pitchFamily="34" charset="-122"/>
                 <a:cs typeface="Calibri" pitchFamily="34" charset="-120"/>
               </a:rPr>
-              <a:t>Ratings fall monotonically from 3.96 (1–3 days) to 3.02 (10+ days). Returned orders average 2.57 vs 3.69 for delivered. Delivery speed is the single strongest lever on satisfaction found in the data (O3).</a:t>
+              <a:t>Ratings fall monotonically from 3.97 (1–3 days) to 3.00 (10+ days). Returned orders average 2.46 vs 3.67 for delivered. Delivery speed is the single strongest lever on satisfaction found in the data (O3).</a:t>
             </a:r>
             <a:endParaRPr lang="en-US" sz="1250" dirty="0"/>
           </a:p>
@@ -6130,6 +6129,10 @@
             <a:prstDash val="solid"/>
           </a:ln>
         </p:spPr>
+        <p:txBody>
+          <a:bodyPr/>
+          <a:p/>
+        </p:txBody>
       </p:sp>
       <p:sp>
         <p:nvSpPr>
@@ -6178,7 +6181,7 @@
                 <a:ea typeface="Calibri" pitchFamily="34" charset="-122"/>
                 <a:cs typeface="Calibri" pitchFamily="34" charset="-120"/>
               </a:rPr>
-              <a:t>Cambodia = 32 % of customers, 35 % of revenue. Indonesia is smallest but has the highest AOV ($155). Referral customers are worth 29 % less than average — the referral scheme attracts low spenders.</a:t>
+              <a:t>Cambodia = 32 % of customers and 32 % of revenue. The Philippines is small but has the highest AOV ($113) and revenue per customer ($242). Referral customers are worth 29 % less than average — the referral scheme attracts low spenders.</a:t>
             </a:r>
             <a:endParaRPr lang="en-US" sz="1250" dirty="0"/>
           </a:p>
@@ -6210,6 +6213,10 @@
             <a:prstDash val="solid"/>
           </a:ln>
         </p:spPr>
+        <p:txBody>
+          <a:bodyPr/>
+          <a:p/>
+        </p:txBody>
       </p:sp>
       <p:sp>
         <p:nvSpPr>
@@ -6258,7 +6265,7 @@
                 <a:ea typeface="Calibri" pitchFamily="34" charset="-122"/>
                 <a:cs typeface="Calibri" pitchFamily="34" charset="-120"/>
               </a:rPr>
-              <a:t>Crosstabs (Q7): Mobile leads every age group (56–64 %). Customers 55+ prefer E-Wallet (38 %) and Bank Transfer (23 %) and rarely use Cash on Delivery (8 % vs 15–18 %). A mobile-first checkout with E-Wallet suits everyone.</a:t>
+              <a:t>Crosstabs (Q7): Mobile leads every age group under 55 (55–63 %). Credit Card leads almost everywhere; the small 55+ group uses Cash on Delivery most (26 % vs 14–17 %). A mobile-first checkout with card and E-Wallet suits nearly everyone.</a:t>
             </a:r>
             <a:endParaRPr lang="en-US" sz="1250" dirty="0"/>
           </a:p>
@@ -6273,6 +6280,1889 @@
 </file>
 
 <file path=ppt/slides/slide13.xml><?xml version="1.0" encoding="utf-8"?>
+<p:sld xmlns:a="http://schemas.openxmlformats.org/drawingml/2006/main" xmlns:p="http://schemas.openxmlformats.org/presentationml/2006/main" xmlns:r="http://schemas.openxmlformats.org/officeDocument/2006/relationships">
+  <p:cSld>
+    <p:spTree>
+      <p:nvGrpSpPr>
+        <p:cNvPr id="1" name=""/>
+        <p:cNvGrpSpPr/>
+        <p:nvPr/>
+      </p:nvGrpSpPr>
+      <p:grpSpPr/>
+      <p:sp>
+        <p:nvSpPr>
+          <p:cNvPr id="2" name="Text 0"/>
+          <p:cNvSpPr txBox="1"/>
+          <p:nvPr/>
+        </p:nvSpPr>
+        <p:spPr>
+          <a:xfrm>
+            <a:off x="548640" y="320040"/>
+            <a:ext cx="11064240" cy="731520"/>
+          </a:xfrm>
+          <a:prstGeom prst="rect">
+            <a:avLst/>
+          </a:prstGeom>
+          <a:noFill/>
+          <a:ln/>
+        </p:spPr>
+        <p:txBody>
+          <a:bodyPr wrap="square" lIns="0" tIns="0" rIns="0" bIns="0" rtlCol="0" anchor="ctr"/>
+          <a:lstStyle/>
+          <a:p>
+            <a:pPr indent="0" marL="0">
+              <a:buNone/>
+            </a:pPr>
+            <a:r>
+              <a:rPr lang="en-US" sz="3200" b="1" dirty="0">
+                <a:solidFill>
+                  <a:srgbClr val="1E2761"/>
+                </a:solidFill>
+                <a:latin typeface="Cambria" pitchFamily="34" charset="0"/>
+                <a:ea typeface="Cambria" pitchFamily="34" charset="-122"/>
+                <a:cs typeface="Cambria" pitchFamily="34" charset="-120"/>
+              </a:rPr>
+              <a:t>Q8 · A few products carry the revenue — two are sold out</a:t>
+            </a:r>
+            <a:endParaRPr lang="en-US" sz="3200" dirty="0"/>
+          </a:p>
+        </p:txBody>
+      </p:sp>
+      <p:sp>
+        <p:nvSpPr>
+          <p:cNvPr id="3" name="Text 1"/>
+          <p:cNvSpPr txBox="1"/>
+          <p:nvPr/>
+        </p:nvSpPr>
+        <p:spPr>
+          <a:xfrm>
+            <a:off x="548640" y="6446520"/>
+            <a:ext cx="11064240" cy="274320"/>
+          </a:xfrm>
+          <a:prstGeom prst="rect">
+            <a:avLst/>
+          </a:prstGeom>
+          <a:noFill/>
+          <a:ln/>
+        </p:spPr>
+        <p:txBody>
+          <a:bodyPr wrap="square" lIns="0" tIns="0" rIns="0" bIns="0" rtlCol="0" anchor="ctr"/>
+          <a:lstStyle/>
+          <a:p>
+            <a:pPr algn="r" indent="0" marL="0">
+              <a:buNone/>
+            </a:pPr>
+            <a:r>
+              <a:rPr lang="en-US" sz="1000" dirty="0">
+                <a:solidFill>
+                  <a:srgbClr val="6B7280"/>
+                </a:solidFill>
+                <a:latin typeface="Calibri" pitchFamily="34" charset="0"/>
+                <a:ea typeface="Calibri" pitchFamily="34" charset="-122"/>
+                <a:cs typeface="Calibri" pitchFamily="34" charset="-120"/>
+              </a:rPr>
+              <a:t>E-commerce Customer Analytics  ·  13</a:t>
+            </a:r>
+            <a:endParaRPr lang="en-US" sz="1000" dirty="0"/>
+          </a:p>
+        </p:txBody>
+      </p:sp>
+      <p:graphicFrame>
+        <p:nvGraphicFramePr>
+          <p:cNvPr id="9" name="Table 0"/>
+          <p:cNvGraphicFramePr>
+            <a:graphicFrameLocks noGrp="1"/>
+          </p:cNvGraphicFramePr>
+          <p:nvPr>
+            <p:extLst>
+              <p:ext uri="{D42A27DB-BD31-4B8C-83A1-F6EECF244321}">
+                <p14:modId xmlns:p14="http://schemas.microsoft.com/office/powerpoint/2010/main" val="1579011935"/>
+              </p:ext>
+            </p:extLst>
+          </p:nvPr>
+        </p:nvGraphicFramePr>
+        <p:xfrm>
+          <a:off x="7406640" y="1280160"/>
+          <a:ext cx="4206240" cy="914400"/>
+        </p:xfrm>
+        <a:graphic>
+          <a:graphicData uri="http://schemas.openxmlformats.org/drawingml/2006/table">
+            <a:tbl>
+              <a:tblPr/>
+              <a:tblGrid>
+                <a:gridCol w="1828800"/>
+                <a:gridCol w="1188720"/>
+                <a:gridCol w="1188720"/>
+              </a:tblGrid>
+              <a:tr h="301752">
+                <a:tc>
+                  <a:txBody>
+                    <a:bodyPr/>
+                    <a:lstStyle/>
+                    <a:p>
+                      <a:pPr algn="l" indent="0" marL="0">
+                        <a:buNone/>
+                      </a:pPr>
+                      <a:r>
+                        <a:rPr lang="en-US" sz="1150" b="1" dirty="0">
+                          <a:solidFill>
+                            <a:srgbClr val="FFFFFF"/>
+                          </a:solidFill>
+                          <a:latin typeface="Calibri" pitchFamily="34" charset="0"/>
+                          <a:ea typeface="Calibri" pitchFamily="34" charset="-122"/>
+                          <a:cs typeface="Calibri" pitchFamily="34" charset="-120"/>
+                        </a:rPr>
+                        <a:t>Product</a:t>
+                      </a:r>
+                      <a:endParaRPr lang="en-US" sz="1150" dirty="0">
+                        <a:latin typeface="Calibri" charset="0"/>
+                        <a:ea typeface="Calibri" charset="0"/>
+                        <a:cs typeface="Calibri" charset="0"/>
+                      </a:endParaRPr>
+                    </a:p>
+                  </a:txBody>
+                  <a:tcPr marL="45720" marR="45720" marT="45720" marB="45720">
+                    <a:lnL w="6350" cap="flat" cmpd="sng" algn="ctr">
+                      <a:solidFill>
+                        <a:srgbClr val="E5E7EB"/>
+                      </a:solidFill>
+                      <a:prstDash val="solid"/>
+                      <a:round/>
+                      <a:headEnd type="none" w="med" len="med"/>
+                      <a:tailEnd type="none" w="med" len="med"/>
+                    </a:lnL>
+                    <a:lnR w="6350" cap="flat" cmpd="sng" algn="ctr">
+                      <a:solidFill>
+                        <a:srgbClr val="E5E7EB"/>
+                      </a:solidFill>
+                      <a:prstDash val="solid"/>
+                      <a:round/>
+                      <a:headEnd type="none" w="med" len="med"/>
+                      <a:tailEnd type="none" w="med" len="med"/>
+                    </a:lnR>
+                    <a:lnT w="6350" cap="flat" cmpd="sng" algn="ctr">
+                      <a:solidFill>
+                        <a:srgbClr val="E5E7EB"/>
+                      </a:solidFill>
+                      <a:prstDash val="solid"/>
+                      <a:round/>
+                      <a:headEnd type="none" w="med" len="med"/>
+                      <a:tailEnd type="none" w="med" len="med"/>
+                    </a:lnT>
+                    <a:lnB w="6350" cap="flat" cmpd="sng" algn="ctr">
+                      <a:solidFill>
+                        <a:srgbClr val="E5E7EB"/>
+                      </a:solidFill>
+                      <a:prstDash val="solid"/>
+                      <a:round/>
+                      <a:headEnd type="none" w="med" len="med"/>
+                      <a:tailEnd type="none" w="med" len="med"/>
+                    </a:lnB>
+                    <a:solidFill>
+                      <a:srgbClr val="1E2761"/>
+                    </a:solidFill>
+                  </a:tcPr>
+                </a:tc>
+                <a:tc>
+                  <a:txBody>
+                    <a:bodyPr/>
+                    <a:lstStyle/>
+                    <a:p>
+                      <a:pPr algn="ctr" indent="0" marL="0">
+                        <a:buNone/>
+                      </a:pPr>
+                      <a:r>
+                        <a:rPr lang="en-US" sz="1150" b="1" dirty="0">
+                          <a:solidFill>
+                            <a:srgbClr val="FFFFFF"/>
+                          </a:solidFill>
+                          <a:latin typeface="Calibri" pitchFamily="34" charset="0"/>
+                          <a:ea typeface="Calibri" pitchFamily="34" charset="-122"/>
+                          <a:cs typeface="Calibri" pitchFamily="34" charset="-120"/>
+                        </a:rPr>
+                        <a:t>Units sold</a:t>
+                      </a:r>
+                      <a:endParaRPr lang="en-US" sz="1150" dirty="0">
+                        <a:latin typeface="Calibri" charset="0"/>
+                        <a:ea typeface="Calibri" charset="0"/>
+                        <a:cs typeface="Calibri" charset="0"/>
+                      </a:endParaRPr>
+                    </a:p>
+                  </a:txBody>
+                  <a:tcPr marL="45720" marR="45720" marT="45720" marB="45720">
+                    <a:lnL w="6350" cap="flat" cmpd="sng" algn="ctr">
+                      <a:solidFill>
+                        <a:srgbClr val="E5E7EB"/>
+                      </a:solidFill>
+                      <a:prstDash val="solid"/>
+                      <a:round/>
+                      <a:headEnd type="none" w="med" len="med"/>
+                      <a:tailEnd type="none" w="med" len="med"/>
+                    </a:lnL>
+                    <a:lnR w="6350" cap="flat" cmpd="sng" algn="ctr">
+                      <a:solidFill>
+                        <a:srgbClr val="E5E7EB"/>
+                      </a:solidFill>
+                      <a:prstDash val="solid"/>
+                      <a:round/>
+                      <a:headEnd type="none" w="med" len="med"/>
+                      <a:tailEnd type="none" w="med" len="med"/>
+                    </a:lnR>
+                    <a:lnT w="6350" cap="flat" cmpd="sng" algn="ctr">
+                      <a:solidFill>
+                        <a:srgbClr val="E5E7EB"/>
+                      </a:solidFill>
+                      <a:prstDash val="solid"/>
+                      <a:round/>
+                      <a:headEnd type="none" w="med" len="med"/>
+                      <a:tailEnd type="none" w="med" len="med"/>
+                    </a:lnT>
+                    <a:lnB w="6350" cap="flat" cmpd="sng" algn="ctr">
+                      <a:solidFill>
+                        <a:srgbClr val="E5E7EB"/>
+                      </a:solidFill>
+                      <a:prstDash val="solid"/>
+                      <a:round/>
+                      <a:headEnd type="none" w="med" len="med"/>
+                      <a:tailEnd type="none" w="med" len="med"/>
+                    </a:lnB>
+                    <a:solidFill>
+                      <a:srgbClr val="1E2761"/>
+                    </a:solidFill>
+                  </a:tcPr>
+                </a:tc>
+                <a:tc>
+                  <a:txBody>
+                    <a:bodyPr/>
+                    <a:lstStyle/>
+                    <a:p>
+                      <a:pPr algn="ctr" indent="0" marL="0">
+                        <a:buNone/>
+                      </a:pPr>
+                      <a:r>
+                        <a:rPr lang="en-US" sz="1150" b="1" dirty="0">
+                          <a:solidFill>
+                            <a:srgbClr val="FFFFFF"/>
+                          </a:solidFill>
+                          <a:latin typeface="Calibri" pitchFamily="34" charset="0"/>
+                          <a:ea typeface="Calibri" pitchFamily="34" charset="-122"/>
+                          <a:cs typeface="Calibri" pitchFamily="34" charset="-120"/>
+                        </a:rPr>
+                        <a:t>Net revenue</a:t>
+                      </a:r>
+                      <a:endParaRPr lang="en-US" sz="1150" dirty="0">
+                        <a:latin typeface="Calibri" charset="0"/>
+                        <a:ea typeface="Calibri" charset="0"/>
+                        <a:cs typeface="Calibri" charset="0"/>
+                      </a:endParaRPr>
+                    </a:p>
+                  </a:txBody>
+                  <a:tcPr marL="45720" marR="45720" marT="45720" marB="45720">
+                    <a:lnL w="6350" cap="flat" cmpd="sng" algn="ctr">
+                      <a:solidFill>
+                        <a:srgbClr val="E5E7EB"/>
+                      </a:solidFill>
+                      <a:prstDash val="solid"/>
+                      <a:round/>
+                      <a:headEnd type="none" w="med" len="med"/>
+                      <a:tailEnd type="none" w="med" len="med"/>
+                    </a:lnL>
+                    <a:lnR w="6350" cap="flat" cmpd="sng" algn="ctr">
+                      <a:solidFill>
+                        <a:srgbClr val="E5E7EB"/>
+                      </a:solidFill>
+                      <a:prstDash val="solid"/>
+                      <a:round/>
+                      <a:headEnd type="none" w="med" len="med"/>
+                      <a:tailEnd type="none" w="med" len="med"/>
+                    </a:lnR>
+                    <a:lnT w="6350" cap="flat" cmpd="sng" algn="ctr">
+                      <a:solidFill>
+                        <a:srgbClr val="E5E7EB"/>
+                      </a:solidFill>
+                      <a:prstDash val="solid"/>
+                      <a:round/>
+                      <a:headEnd type="none" w="med" len="med"/>
+                      <a:tailEnd type="none" w="med" len="med"/>
+                    </a:lnT>
+                    <a:lnB w="6350" cap="flat" cmpd="sng" algn="ctr">
+                      <a:solidFill>
+                        <a:srgbClr val="E5E7EB"/>
+                      </a:solidFill>
+                      <a:prstDash val="solid"/>
+                      <a:round/>
+                      <a:headEnd type="none" w="med" len="med"/>
+                      <a:tailEnd type="none" w="med" len="med"/>
+                    </a:lnB>
+                    <a:solidFill>
+                      <a:srgbClr val="1E2761"/>
+                    </a:solidFill>
+                  </a:tcPr>
+                </a:tc>
+              </a:tr>
+              <a:tr h="301752">
+                <a:tc>
+                  <a:txBody>
+                    <a:bodyPr/>
+                    <a:lstStyle/>
+                    <a:p>
+                      <a:pPr algn="l" indent="0" marL="0">
+                        <a:buNone/>
+                      </a:pPr>
+                      <a:r>
+                        <a:rPr lang="en-US" sz="1150" dirty="0">
+                          <a:solidFill>
+                            <a:srgbClr val="1F2937"/>
+                          </a:solidFill>
+                          <a:latin typeface="Calibri" pitchFamily="34" charset="0"/>
+                          <a:ea typeface="Calibri" pitchFamily="34" charset="-122"/>
+                          <a:cs typeface="Calibri" pitchFamily="34" charset="-120"/>
+                        </a:rPr>
+                        <a:t>Smartphone A54 128GB</a:t>
+                      </a:r>
+                      <a:endParaRPr lang="en-US" sz="1150" dirty="0">
+                        <a:latin typeface="Calibri" charset="0"/>
+                        <a:ea typeface="Calibri" charset="0"/>
+                        <a:cs typeface="Calibri" charset="0"/>
+                      </a:endParaRPr>
+                    </a:p>
+                  </a:txBody>
+                  <a:tcPr marL="45720" marR="45720" marT="45720" marB="45720">
+                    <a:lnL w="6350" cap="flat" cmpd="sng" algn="ctr">
+                      <a:solidFill>
+                        <a:srgbClr val="E5E7EB"/>
+                      </a:solidFill>
+                      <a:prstDash val="solid"/>
+                      <a:round/>
+                      <a:headEnd type="none" w="med" len="med"/>
+                      <a:tailEnd type="none" w="med" len="med"/>
+                    </a:lnL>
+                    <a:lnR w="6350" cap="flat" cmpd="sng" algn="ctr">
+                      <a:solidFill>
+                        <a:srgbClr val="E5E7EB"/>
+                      </a:solidFill>
+                      <a:prstDash val="solid"/>
+                      <a:round/>
+                      <a:headEnd type="none" w="med" len="med"/>
+                      <a:tailEnd type="none" w="med" len="med"/>
+                    </a:lnR>
+                    <a:lnT w="6350" cap="flat" cmpd="sng" algn="ctr">
+                      <a:solidFill>
+                        <a:srgbClr val="E5E7EB"/>
+                      </a:solidFill>
+                      <a:prstDash val="solid"/>
+                      <a:round/>
+                      <a:headEnd type="none" w="med" len="med"/>
+                      <a:tailEnd type="none" w="med" len="med"/>
+                    </a:lnT>
+                    <a:lnB w="6350" cap="flat" cmpd="sng" algn="ctr">
+                      <a:solidFill>
+                        <a:srgbClr val="E5E7EB"/>
+                      </a:solidFill>
+                      <a:prstDash val="solid"/>
+                      <a:round/>
+                      <a:headEnd type="none" w="med" len="med"/>
+                      <a:tailEnd type="none" w="med" len="med"/>
+                    </a:lnB>
+                    <a:solidFill>
+                      <a:srgbClr val="F3F6FC"/>
+                    </a:solidFill>
+                  </a:tcPr>
+                </a:tc>
+                <a:tc>
+                  <a:txBody>
+                    <a:bodyPr/>
+                    <a:lstStyle/>
+                    <a:p>
+                      <a:pPr algn="ctr" indent="0" marL="0">
+                        <a:buNone/>
+                      </a:pPr>
+                      <a:r>
+                        <a:rPr lang="en-US" sz="1150" dirty="0">
+                          <a:solidFill>
+                            <a:srgbClr val="1F2937"/>
+                          </a:solidFill>
+                          <a:latin typeface="Calibri" pitchFamily="34" charset="0"/>
+                          <a:ea typeface="Calibri" pitchFamily="34" charset="-122"/>
+                          <a:cs typeface="Calibri" pitchFamily="34" charset="-120"/>
+                        </a:rPr>
+                        <a:t>52</a:t>
+                      </a:r>
+                      <a:endParaRPr lang="en-US" sz="1150" dirty="0">
+                        <a:latin typeface="Calibri" charset="0"/>
+                        <a:ea typeface="Calibri" charset="0"/>
+                        <a:cs typeface="Calibri" charset="0"/>
+                      </a:endParaRPr>
+                    </a:p>
+                  </a:txBody>
+                  <a:tcPr marL="45720" marR="45720" marT="45720" marB="45720">
+                    <a:lnL w="6350" cap="flat" cmpd="sng" algn="ctr">
+                      <a:solidFill>
+                        <a:srgbClr val="E5E7EB"/>
+                      </a:solidFill>
+                      <a:prstDash val="solid"/>
+                      <a:round/>
+                      <a:headEnd type="none" w="med" len="med"/>
+                      <a:tailEnd type="none" w="med" len="med"/>
+                    </a:lnL>
+                    <a:lnR w="6350" cap="flat" cmpd="sng" algn="ctr">
+                      <a:solidFill>
+                        <a:srgbClr val="E5E7EB"/>
+                      </a:solidFill>
+                      <a:prstDash val="solid"/>
+                      <a:round/>
+                      <a:headEnd type="none" w="med" len="med"/>
+                      <a:tailEnd type="none" w="med" len="med"/>
+                    </a:lnR>
+                    <a:lnT w="6350" cap="flat" cmpd="sng" algn="ctr">
+                      <a:solidFill>
+                        <a:srgbClr val="E5E7EB"/>
+                      </a:solidFill>
+                      <a:prstDash val="solid"/>
+                      <a:round/>
+                      <a:headEnd type="none" w="med" len="med"/>
+                      <a:tailEnd type="none" w="med" len="med"/>
+                    </a:lnT>
+                    <a:lnB w="6350" cap="flat" cmpd="sng" algn="ctr">
+                      <a:solidFill>
+                        <a:srgbClr val="E5E7EB"/>
+                      </a:solidFill>
+                      <a:prstDash val="solid"/>
+                      <a:round/>
+                      <a:headEnd type="none" w="med" len="med"/>
+                      <a:tailEnd type="none" w="med" len="med"/>
+                    </a:lnB>
+                    <a:solidFill>
+                      <a:srgbClr val="F3F6FC"/>
+                    </a:solidFill>
+                  </a:tcPr>
+                </a:tc>
+                <a:tc>
+                  <a:txBody>
+                    <a:bodyPr/>
+                    <a:lstStyle/>
+                    <a:p>
+                      <a:pPr algn="ctr" indent="0" marL="0">
+                        <a:buNone/>
+                      </a:pPr>
+                      <a:r>
+                        <a:rPr lang="en-US" sz="1150" dirty="0">
+                          <a:solidFill>
+                            <a:srgbClr val="1F2937"/>
+                          </a:solidFill>
+                          <a:latin typeface="Calibri" pitchFamily="34" charset="0"/>
+                          <a:ea typeface="Calibri" pitchFamily="34" charset="-122"/>
+                          <a:cs typeface="Calibri" pitchFamily="34" charset="-120"/>
+                        </a:rPr>
+                        <a:t>$16.6k</a:t>
+                      </a:r>
+                      <a:endParaRPr lang="en-US" sz="1150" dirty="0">
+                        <a:latin typeface="Calibri" charset="0"/>
+                        <a:ea typeface="Calibri" charset="0"/>
+                        <a:cs typeface="Calibri" charset="0"/>
+                      </a:endParaRPr>
+                    </a:p>
+                  </a:txBody>
+                  <a:tcPr marL="45720" marR="45720" marT="45720" marB="45720">
+                    <a:lnL w="6350" cap="flat" cmpd="sng" algn="ctr">
+                      <a:solidFill>
+                        <a:srgbClr val="E5E7EB"/>
+                      </a:solidFill>
+                      <a:prstDash val="solid"/>
+                      <a:round/>
+                      <a:headEnd type="none" w="med" len="med"/>
+                      <a:tailEnd type="none" w="med" len="med"/>
+                    </a:lnL>
+                    <a:lnR w="6350" cap="flat" cmpd="sng" algn="ctr">
+                      <a:solidFill>
+                        <a:srgbClr val="E5E7EB"/>
+                      </a:solidFill>
+                      <a:prstDash val="solid"/>
+                      <a:round/>
+                      <a:headEnd type="none" w="med" len="med"/>
+                      <a:tailEnd type="none" w="med" len="med"/>
+                    </a:lnR>
+                    <a:lnT w="6350" cap="flat" cmpd="sng" algn="ctr">
+                      <a:solidFill>
+                        <a:srgbClr val="E5E7EB"/>
+                      </a:solidFill>
+                      <a:prstDash val="solid"/>
+                      <a:round/>
+                      <a:headEnd type="none" w="med" len="med"/>
+                      <a:tailEnd type="none" w="med" len="med"/>
+                    </a:lnT>
+                    <a:lnB w="6350" cap="flat" cmpd="sng" algn="ctr">
+                      <a:solidFill>
+                        <a:srgbClr val="E5E7EB"/>
+                      </a:solidFill>
+                      <a:prstDash val="solid"/>
+                      <a:round/>
+                      <a:headEnd type="none" w="med" len="med"/>
+                      <a:tailEnd type="none" w="med" len="med"/>
+                    </a:lnB>
+                    <a:solidFill>
+                      <a:srgbClr val="F3F6FC"/>
+                    </a:solidFill>
+                  </a:tcPr>
+                </a:tc>
+              </a:tr>
+              <a:tr h="301752">
+                <a:tc>
+                  <a:txBody>
+                    <a:bodyPr/>
+                    <a:lstStyle/>
+                    <a:p>
+                      <a:pPr algn="l" indent="0" marL="0">
+                        <a:buNone/>
+                      </a:pPr>
+                      <a:r>
+                        <a:rPr lang="en-US" sz="1150" dirty="0">
+                          <a:solidFill>
+                            <a:srgbClr val="1F2937"/>
+                          </a:solidFill>
+                          <a:latin typeface="Calibri" pitchFamily="34" charset="0"/>
+                          <a:ea typeface="Calibri" pitchFamily="34" charset="-122"/>
+                          <a:cs typeface="Calibri" pitchFamily="34" charset="-120"/>
+                        </a:rPr>
+                        <a:t>14-inch Laptop</a:t>
+                      </a:r>
+                      <a:endParaRPr lang="en-US" sz="1150" dirty="0">
+                        <a:latin typeface="Calibri" charset="0"/>
+                        <a:ea typeface="Calibri" charset="0"/>
+                        <a:cs typeface="Calibri" charset="0"/>
+                      </a:endParaRPr>
+                    </a:p>
+                  </a:txBody>
+                  <a:tcPr marL="45720" marR="45720" marT="45720" marB="45720">
+                    <a:lnL w="6350" cap="flat" cmpd="sng" algn="ctr">
+                      <a:solidFill>
+                        <a:srgbClr val="E5E7EB"/>
+                      </a:solidFill>
+                      <a:prstDash val="solid"/>
+                      <a:round/>
+                      <a:headEnd type="none" w="med" len="med"/>
+                      <a:tailEnd type="none" w="med" len="med"/>
+                    </a:lnL>
+                    <a:lnR w="6350" cap="flat" cmpd="sng" algn="ctr">
+                      <a:solidFill>
+                        <a:srgbClr val="E5E7EB"/>
+                      </a:solidFill>
+                      <a:prstDash val="solid"/>
+                      <a:round/>
+                      <a:headEnd type="none" w="med" len="med"/>
+                      <a:tailEnd type="none" w="med" len="med"/>
+                    </a:lnR>
+                    <a:lnT w="6350" cap="flat" cmpd="sng" algn="ctr">
+                      <a:solidFill>
+                        <a:srgbClr val="E5E7EB"/>
+                      </a:solidFill>
+                      <a:prstDash val="solid"/>
+                      <a:round/>
+                      <a:headEnd type="none" w="med" len="med"/>
+                      <a:tailEnd type="none" w="med" len="med"/>
+                    </a:lnT>
+                    <a:lnB w="6350" cap="flat" cmpd="sng" algn="ctr">
+                      <a:solidFill>
+                        <a:srgbClr val="E5E7EB"/>
+                      </a:solidFill>
+                      <a:prstDash val="solid"/>
+                      <a:round/>
+                      <a:headEnd type="none" w="med" len="med"/>
+                      <a:tailEnd type="none" w="med" len="med"/>
+                    </a:lnB>
+                    <a:solidFill>
+                      <a:srgbClr val="FFFFFF"/>
+                    </a:solidFill>
+                  </a:tcPr>
+                </a:tc>
+                <a:tc>
+                  <a:txBody>
+                    <a:bodyPr/>
+                    <a:lstStyle/>
+                    <a:p>
+                      <a:pPr algn="ctr" indent="0" marL="0">
+                        <a:buNone/>
+                      </a:pPr>
+                      <a:r>
+                        <a:rPr lang="en-US" sz="1150" dirty="0">
+                          <a:solidFill>
+                            <a:srgbClr val="1F2937"/>
+                          </a:solidFill>
+                          <a:latin typeface="Calibri" pitchFamily="34" charset="0"/>
+                          <a:ea typeface="Calibri" pitchFamily="34" charset="-122"/>
+                          <a:cs typeface="Calibri" pitchFamily="34" charset="-120"/>
+                        </a:rPr>
+                        <a:t>20</a:t>
+                      </a:r>
+                      <a:endParaRPr lang="en-US" sz="1150" dirty="0">
+                        <a:latin typeface="Calibri" charset="0"/>
+                        <a:ea typeface="Calibri" charset="0"/>
+                        <a:cs typeface="Calibri" charset="0"/>
+                      </a:endParaRPr>
+                    </a:p>
+                  </a:txBody>
+                  <a:tcPr marL="45720" marR="45720" marT="45720" marB="45720">
+                    <a:lnL w="6350" cap="flat" cmpd="sng" algn="ctr">
+                      <a:solidFill>
+                        <a:srgbClr val="E5E7EB"/>
+                      </a:solidFill>
+                      <a:prstDash val="solid"/>
+                      <a:round/>
+                      <a:headEnd type="none" w="med" len="med"/>
+                      <a:tailEnd type="none" w="med" len="med"/>
+                    </a:lnL>
+                    <a:lnR w="6350" cap="flat" cmpd="sng" algn="ctr">
+                      <a:solidFill>
+                        <a:srgbClr val="E5E7EB"/>
+                      </a:solidFill>
+                      <a:prstDash val="solid"/>
+                      <a:round/>
+                      <a:headEnd type="none" w="med" len="med"/>
+                      <a:tailEnd type="none" w="med" len="med"/>
+                    </a:lnR>
+                    <a:lnT w="6350" cap="flat" cmpd="sng" algn="ctr">
+                      <a:solidFill>
+                        <a:srgbClr val="E5E7EB"/>
+                      </a:solidFill>
+                      <a:prstDash val="solid"/>
+                      <a:round/>
+                      <a:headEnd type="none" w="med" len="med"/>
+                      <a:tailEnd type="none" w="med" len="med"/>
+                    </a:lnT>
+                    <a:lnB w="6350" cap="flat" cmpd="sng" algn="ctr">
+                      <a:solidFill>
+                        <a:srgbClr val="E5E7EB"/>
+                      </a:solidFill>
+                      <a:prstDash val="solid"/>
+                      <a:round/>
+                      <a:headEnd type="none" w="med" len="med"/>
+                      <a:tailEnd type="none" w="med" len="med"/>
+                    </a:lnB>
+                    <a:solidFill>
+                      <a:srgbClr val="FFFFFF"/>
+                    </a:solidFill>
+                  </a:tcPr>
+                </a:tc>
+                <a:tc>
+                  <a:txBody>
+                    <a:bodyPr/>
+                    <a:lstStyle/>
+                    <a:p>
+                      <a:pPr algn="ctr" indent="0" marL="0">
+                        <a:buNone/>
+                      </a:pPr>
+                      <a:r>
+                        <a:rPr lang="en-US" sz="1150" dirty="0">
+                          <a:solidFill>
+                            <a:srgbClr val="1F2937"/>
+                          </a:solidFill>
+                          <a:latin typeface="Calibri" pitchFamily="34" charset="0"/>
+                          <a:ea typeface="Calibri" pitchFamily="34" charset="-122"/>
+                          <a:cs typeface="Calibri" pitchFamily="34" charset="-120"/>
+                        </a:rPr>
+                        <a:t>$11.6k</a:t>
+                      </a:r>
+                      <a:endParaRPr lang="en-US" sz="1150" dirty="0">
+                        <a:latin typeface="Calibri" charset="0"/>
+                        <a:ea typeface="Calibri" charset="0"/>
+                        <a:cs typeface="Calibri" charset="0"/>
+                      </a:endParaRPr>
+                    </a:p>
+                  </a:txBody>
+                  <a:tcPr marL="45720" marR="45720" marT="45720" marB="45720">
+                    <a:lnL w="6350" cap="flat" cmpd="sng" algn="ctr">
+                      <a:solidFill>
+                        <a:srgbClr val="E5E7EB"/>
+                      </a:solidFill>
+                      <a:prstDash val="solid"/>
+                      <a:round/>
+                      <a:headEnd type="none" w="med" len="med"/>
+                      <a:tailEnd type="none" w="med" len="med"/>
+                    </a:lnL>
+                    <a:lnR w="6350" cap="flat" cmpd="sng" algn="ctr">
+                      <a:solidFill>
+                        <a:srgbClr val="E5E7EB"/>
+                      </a:solidFill>
+                      <a:prstDash val="solid"/>
+                      <a:round/>
+                      <a:headEnd type="none" w="med" len="med"/>
+                      <a:tailEnd type="none" w="med" len="med"/>
+                    </a:lnR>
+                    <a:lnT w="6350" cap="flat" cmpd="sng" algn="ctr">
+                      <a:solidFill>
+                        <a:srgbClr val="E5E7EB"/>
+                      </a:solidFill>
+                      <a:prstDash val="solid"/>
+                      <a:round/>
+                      <a:headEnd type="none" w="med" len="med"/>
+                      <a:tailEnd type="none" w="med" len="med"/>
+                    </a:lnT>
+                    <a:lnB w="6350" cap="flat" cmpd="sng" algn="ctr">
+                      <a:solidFill>
+                        <a:srgbClr val="E5E7EB"/>
+                      </a:solidFill>
+                      <a:prstDash val="solid"/>
+                      <a:round/>
+                      <a:headEnd type="none" w="med" len="med"/>
+                      <a:tailEnd type="none" w="med" len="med"/>
+                    </a:lnB>
+                    <a:solidFill>
+                      <a:srgbClr val="FFFFFF"/>
+                    </a:solidFill>
+                  </a:tcPr>
+                </a:tc>
+              </a:tr>
+              <a:tr h="301752">
+                <a:tc>
+                  <a:txBody>
+                    <a:bodyPr/>
+                    <a:lstStyle/>
+                    <a:p>
+                      <a:pPr algn="l" indent="0" marL="0">
+                        <a:buNone/>
+                      </a:pPr>
+                      <a:r>
+                        <a:rPr lang="en-US" sz="1150" dirty="0">
+                          <a:solidFill>
+                            <a:srgbClr val="1F2937"/>
+                          </a:solidFill>
+                          <a:latin typeface="Calibri" pitchFamily="34" charset="0"/>
+                          <a:ea typeface="Calibri" pitchFamily="34" charset="-122"/>
+                          <a:cs typeface="Calibri" pitchFamily="34" charset="-120"/>
+                        </a:rPr>
+                        <a:t>10-inch Android Tablet</a:t>
+                      </a:r>
+                      <a:endParaRPr lang="en-US" sz="1150" dirty="0">
+                        <a:latin typeface="Calibri" charset="0"/>
+                        <a:ea typeface="Calibri" charset="0"/>
+                        <a:cs typeface="Calibri" charset="0"/>
+                      </a:endParaRPr>
+                    </a:p>
+                  </a:txBody>
+                  <a:tcPr marL="45720" marR="45720" marT="45720" marB="45720">
+                    <a:lnL w="6350" cap="flat" cmpd="sng" algn="ctr">
+                      <a:solidFill>
+                        <a:srgbClr val="E5E7EB"/>
+                      </a:solidFill>
+                      <a:prstDash val="solid"/>
+                      <a:round/>
+                      <a:headEnd type="none" w="med" len="med"/>
+                      <a:tailEnd type="none" w="med" len="med"/>
+                    </a:lnL>
+                    <a:lnR w="6350" cap="flat" cmpd="sng" algn="ctr">
+                      <a:solidFill>
+                        <a:srgbClr val="E5E7EB"/>
+                      </a:solidFill>
+                      <a:prstDash val="solid"/>
+                      <a:round/>
+                      <a:headEnd type="none" w="med" len="med"/>
+                      <a:tailEnd type="none" w="med" len="med"/>
+                    </a:lnR>
+                    <a:lnT w="6350" cap="flat" cmpd="sng" algn="ctr">
+                      <a:solidFill>
+                        <a:srgbClr val="E5E7EB"/>
+                      </a:solidFill>
+                      <a:prstDash val="solid"/>
+                      <a:round/>
+                      <a:headEnd type="none" w="med" len="med"/>
+                      <a:tailEnd type="none" w="med" len="med"/>
+                    </a:lnT>
+                    <a:lnB w="6350" cap="flat" cmpd="sng" algn="ctr">
+                      <a:solidFill>
+                        <a:srgbClr val="E5E7EB"/>
+                      </a:solidFill>
+                      <a:prstDash val="solid"/>
+                      <a:round/>
+                      <a:headEnd type="none" w="med" len="med"/>
+                      <a:tailEnd type="none" w="med" len="med"/>
+                    </a:lnB>
+                    <a:solidFill>
+                      <a:srgbClr val="F3F6FC"/>
+                    </a:solidFill>
+                  </a:tcPr>
+                </a:tc>
+                <a:tc>
+                  <a:txBody>
+                    <a:bodyPr/>
+                    <a:lstStyle/>
+                    <a:p>
+                      <a:pPr algn="ctr" indent="0" marL="0">
+                        <a:buNone/>
+                      </a:pPr>
+                      <a:r>
+                        <a:rPr lang="en-US" sz="1150" dirty="0">
+                          <a:solidFill>
+                            <a:srgbClr val="1F2937"/>
+                          </a:solidFill>
+                          <a:latin typeface="Calibri" pitchFamily="34" charset="0"/>
+                          <a:ea typeface="Calibri" pitchFamily="34" charset="-122"/>
+                          <a:cs typeface="Calibri" pitchFamily="34" charset="-120"/>
+                        </a:rPr>
+                        <a:t>41</a:t>
+                      </a:r>
+                      <a:endParaRPr lang="en-US" sz="1150" dirty="0">
+                        <a:latin typeface="Calibri" charset="0"/>
+                        <a:ea typeface="Calibri" charset="0"/>
+                        <a:cs typeface="Calibri" charset="0"/>
+                      </a:endParaRPr>
+                    </a:p>
+                  </a:txBody>
+                  <a:tcPr marL="45720" marR="45720" marT="45720" marB="45720">
+                    <a:lnL w="6350" cap="flat" cmpd="sng" algn="ctr">
+                      <a:solidFill>
+                        <a:srgbClr val="E5E7EB"/>
+                      </a:solidFill>
+                      <a:prstDash val="solid"/>
+                      <a:round/>
+                      <a:headEnd type="none" w="med" len="med"/>
+                      <a:tailEnd type="none" w="med" len="med"/>
+                    </a:lnL>
+                    <a:lnR w="6350" cap="flat" cmpd="sng" algn="ctr">
+                      <a:solidFill>
+                        <a:srgbClr val="E5E7EB"/>
+                      </a:solidFill>
+                      <a:prstDash val="solid"/>
+                      <a:round/>
+                      <a:headEnd type="none" w="med" len="med"/>
+                      <a:tailEnd type="none" w="med" len="med"/>
+                    </a:lnR>
+                    <a:lnT w="6350" cap="flat" cmpd="sng" algn="ctr">
+                      <a:solidFill>
+                        <a:srgbClr val="E5E7EB"/>
+                      </a:solidFill>
+                      <a:prstDash val="solid"/>
+                      <a:round/>
+                      <a:headEnd type="none" w="med" len="med"/>
+                      <a:tailEnd type="none" w="med" len="med"/>
+                    </a:lnT>
+                    <a:lnB w="6350" cap="flat" cmpd="sng" algn="ctr">
+                      <a:solidFill>
+                        <a:srgbClr val="E5E7EB"/>
+                      </a:solidFill>
+                      <a:prstDash val="solid"/>
+                      <a:round/>
+                      <a:headEnd type="none" w="med" len="med"/>
+                      <a:tailEnd type="none" w="med" len="med"/>
+                    </a:lnB>
+                    <a:solidFill>
+                      <a:srgbClr val="F3F6FC"/>
+                    </a:solidFill>
+                  </a:tcPr>
+                </a:tc>
+                <a:tc>
+                  <a:txBody>
+                    <a:bodyPr/>
+                    <a:lstStyle/>
+                    <a:p>
+                      <a:pPr algn="ctr" indent="0" marL="0">
+                        <a:buNone/>
+                      </a:pPr>
+                      <a:r>
+                        <a:rPr lang="en-US" sz="1150" dirty="0">
+                          <a:solidFill>
+                            <a:srgbClr val="EF4444"/>
+                          </a:solidFill>
+                          <a:latin typeface="Calibri" pitchFamily="34" charset="0"/>
+                          <a:ea typeface="Calibri" pitchFamily="34" charset="-122"/>
+                          <a:cs typeface="Calibri" pitchFamily="34" charset="-120"/>
+                        </a:rPr>
+                        <a:t>$8.6k</a:t>
+                      </a:r>
+                      <a:endParaRPr lang="en-US" sz="1150" dirty="0">
+                        <a:latin typeface="Calibri" charset="0"/>
+                        <a:ea typeface="Calibri" charset="0"/>
+                        <a:cs typeface="Calibri" charset="0"/>
+                      </a:endParaRPr>
+                    </a:p>
+                  </a:txBody>
+                  <a:tcPr marL="45720" marR="45720" marT="45720" marB="45720">
+                    <a:lnL w="6350" cap="flat" cmpd="sng" algn="ctr">
+                      <a:solidFill>
+                        <a:srgbClr val="E5E7EB"/>
+                      </a:solidFill>
+                      <a:prstDash val="solid"/>
+                      <a:round/>
+                      <a:headEnd type="none" w="med" len="med"/>
+                      <a:tailEnd type="none" w="med" len="med"/>
+                    </a:lnL>
+                    <a:lnR w="6350" cap="flat" cmpd="sng" algn="ctr">
+                      <a:solidFill>
+                        <a:srgbClr val="E5E7EB"/>
+                      </a:solidFill>
+                      <a:prstDash val="solid"/>
+                      <a:round/>
+                      <a:headEnd type="none" w="med" len="med"/>
+                      <a:tailEnd type="none" w="med" len="med"/>
+                    </a:lnR>
+                    <a:lnT w="6350" cap="flat" cmpd="sng" algn="ctr">
+                      <a:solidFill>
+                        <a:srgbClr val="E5E7EB"/>
+                      </a:solidFill>
+                      <a:prstDash val="solid"/>
+                      <a:round/>
+                      <a:headEnd type="none" w="med" len="med"/>
+                      <a:tailEnd type="none" w="med" len="med"/>
+                    </a:lnT>
+                    <a:lnB w="6350" cap="flat" cmpd="sng" algn="ctr">
+                      <a:solidFill>
+                        <a:srgbClr val="E5E7EB"/>
+                      </a:solidFill>
+                      <a:prstDash val="solid"/>
+                      <a:round/>
+                      <a:headEnd type="none" w="med" len="med"/>
+                      <a:tailEnd type="none" w="med" len="med"/>
+                    </a:lnB>
+                    <a:solidFill>
+                      <a:srgbClr val="F3F6FC"/>
+                    </a:solidFill>
+                  </a:tcPr>
+                </a:tc>
+              </a:tr>
+              <a:tr h="301752">
+                <a:tc>
+                  <a:txBody>
+                    <a:bodyPr/>
+                    <a:lstStyle/>
+                    <a:p>
+                      <a:pPr algn="l" indent="0" marL="0">
+                        <a:buNone/>
+                      </a:pPr>
+                      <a:r>
+                        <a:rPr lang="en-US" sz="1150" dirty="0">
+                          <a:solidFill>
+                            <a:srgbClr val="1F2937"/>
+                          </a:solidFill>
+                          <a:latin typeface="Calibri" pitchFamily="34" charset="0"/>
+                          <a:ea typeface="Calibri" pitchFamily="34" charset="-122"/>
+                          <a:cs typeface="Calibri" pitchFamily="34" charset="-120"/>
+                        </a:rPr>
+                        <a:t>4L Air Fryer</a:t>
+                      </a:r>
+                      <a:endParaRPr lang="en-US" sz="1150" dirty="0">
+                        <a:latin typeface="Calibri" charset="0"/>
+                        <a:ea typeface="Calibri" charset="0"/>
+                        <a:cs typeface="Calibri" charset="0"/>
+                      </a:endParaRPr>
+                    </a:p>
+                  </a:txBody>
+                  <a:tcPr marL="45720" marR="45720" marT="45720" marB="45720">
+                    <a:lnL w="6350" cap="flat" cmpd="sng" algn="ctr">
+                      <a:solidFill>
+                        <a:srgbClr val="E5E7EB"/>
+                      </a:solidFill>
+                      <a:prstDash val="solid"/>
+                      <a:round/>
+                      <a:headEnd type="none" w="med" len="med"/>
+                      <a:tailEnd type="none" w="med" len="med"/>
+                    </a:lnL>
+                    <a:lnR w="6350" cap="flat" cmpd="sng" algn="ctr">
+                      <a:solidFill>
+                        <a:srgbClr val="E5E7EB"/>
+                      </a:solidFill>
+                      <a:prstDash val="solid"/>
+                      <a:round/>
+                      <a:headEnd type="none" w="med" len="med"/>
+                      <a:tailEnd type="none" w="med" len="med"/>
+                    </a:lnR>
+                    <a:lnT w="6350" cap="flat" cmpd="sng" algn="ctr">
+                      <a:solidFill>
+                        <a:srgbClr val="E5E7EB"/>
+                      </a:solidFill>
+                      <a:prstDash val="solid"/>
+                      <a:round/>
+                      <a:headEnd type="none" w="med" len="med"/>
+                      <a:tailEnd type="none" w="med" len="med"/>
+                    </a:lnT>
+                    <a:lnB w="6350" cap="flat" cmpd="sng" algn="ctr">
+                      <a:solidFill>
+                        <a:srgbClr val="E5E7EB"/>
+                      </a:solidFill>
+                      <a:prstDash val="solid"/>
+                      <a:round/>
+                      <a:headEnd type="none" w="med" len="med"/>
+                      <a:tailEnd type="none" w="med" len="med"/>
+                    </a:lnB>
+                    <a:solidFill>
+                      <a:srgbClr val="FFFFFF"/>
+                    </a:solidFill>
+                  </a:tcPr>
+                </a:tc>
+                <a:tc>
+                  <a:txBody>
+                    <a:bodyPr/>
+                    <a:lstStyle/>
+                    <a:p>
+                      <a:pPr algn="ctr" indent="0" marL="0">
+                        <a:buNone/>
+                      </a:pPr>
+                      <a:r>
+                        <a:rPr lang="en-US" sz="1150" dirty="0">
+                          <a:solidFill>
+                            <a:srgbClr val="1F2937"/>
+                          </a:solidFill>
+                          <a:latin typeface="Calibri" pitchFamily="34" charset="0"/>
+                          <a:ea typeface="Calibri" pitchFamily="34" charset="-122"/>
+                          <a:cs typeface="Calibri" pitchFamily="34" charset="-120"/>
+                        </a:rPr>
+                        <a:t>67</a:t>
+                      </a:r>
+                      <a:endParaRPr lang="en-US" sz="1150" dirty="0">
+                        <a:latin typeface="Calibri" charset="0"/>
+                        <a:ea typeface="Calibri" charset="0"/>
+                        <a:cs typeface="Calibri" charset="0"/>
+                      </a:endParaRPr>
+                    </a:p>
+                  </a:txBody>
+                  <a:tcPr marL="45720" marR="45720" marT="45720" marB="45720">
+                    <a:lnL w="6350" cap="flat" cmpd="sng" algn="ctr">
+                      <a:solidFill>
+                        <a:srgbClr val="E5E7EB"/>
+                      </a:solidFill>
+                      <a:prstDash val="solid"/>
+                      <a:round/>
+                      <a:headEnd type="none" w="med" len="med"/>
+                      <a:tailEnd type="none" w="med" len="med"/>
+                    </a:lnL>
+                    <a:lnR w="6350" cap="flat" cmpd="sng" algn="ctr">
+                      <a:solidFill>
+                        <a:srgbClr val="E5E7EB"/>
+                      </a:solidFill>
+                      <a:prstDash val="solid"/>
+                      <a:round/>
+                      <a:headEnd type="none" w="med" len="med"/>
+                      <a:tailEnd type="none" w="med" len="med"/>
+                    </a:lnR>
+                    <a:lnT w="6350" cap="flat" cmpd="sng" algn="ctr">
+                      <a:solidFill>
+                        <a:srgbClr val="E5E7EB"/>
+                      </a:solidFill>
+                      <a:prstDash val="solid"/>
+                      <a:round/>
+                      <a:headEnd type="none" w="med" len="med"/>
+                      <a:tailEnd type="none" w="med" len="med"/>
+                    </a:lnT>
+                    <a:lnB w="6350" cap="flat" cmpd="sng" algn="ctr">
+                      <a:solidFill>
+                        <a:srgbClr val="E5E7EB"/>
+                      </a:solidFill>
+                      <a:prstDash val="solid"/>
+                      <a:round/>
+                      <a:headEnd type="none" w="med" len="med"/>
+                      <a:tailEnd type="none" w="med" len="med"/>
+                    </a:lnB>
+                    <a:solidFill>
+                      <a:srgbClr val="FFFFFF"/>
+                    </a:solidFill>
+                  </a:tcPr>
+                </a:tc>
+                <a:tc>
+                  <a:txBody>
+                    <a:bodyPr/>
+                    <a:lstStyle/>
+                    <a:p>
+                      <a:pPr algn="ctr" indent="0" marL="0">
+                        <a:buNone/>
+                      </a:pPr>
+                      <a:r>
+                        <a:rPr lang="en-US" sz="1150" dirty="0">
+                          <a:solidFill>
+                            <a:srgbClr val="1F2937"/>
+                          </a:solidFill>
+                          <a:latin typeface="Calibri" pitchFamily="34" charset="0"/>
+                          <a:ea typeface="Calibri" pitchFamily="34" charset="-122"/>
+                          <a:cs typeface="Calibri" pitchFamily="34" charset="-120"/>
+                        </a:rPr>
+                        <a:t>$7.4k</a:t>
+                      </a:r>
+                      <a:endParaRPr lang="en-US" sz="1150" dirty="0">
+                        <a:latin typeface="Calibri" charset="0"/>
+                        <a:ea typeface="Calibri" charset="0"/>
+                        <a:cs typeface="Calibri" charset="0"/>
+                      </a:endParaRPr>
+                    </a:p>
+                  </a:txBody>
+                  <a:tcPr marL="45720" marR="45720" marT="45720" marB="45720">
+                    <a:lnL w="6350" cap="flat" cmpd="sng" algn="ctr">
+                      <a:solidFill>
+                        <a:srgbClr val="E5E7EB"/>
+                      </a:solidFill>
+                      <a:prstDash val="solid"/>
+                      <a:round/>
+                      <a:headEnd type="none" w="med" len="med"/>
+                      <a:tailEnd type="none" w="med" len="med"/>
+                    </a:lnL>
+                    <a:lnR w="6350" cap="flat" cmpd="sng" algn="ctr">
+                      <a:solidFill>
+                        <a:srgbClr val="E5E7EB"/>
+                      </a:solidFill>
+                      <a:prstDash val="solid"/>
+                      <a:round/>
+                      <a:headEnd type="none" w="med" len="med"/>
+                      <a:tailEnd type="none" w="med" len="med"/>
+                    </a:lnR>
+                    <a:lnT w="6350" cap="flat" cmpd="sng" algn="ctr">
+                      <a:solidFill>
+                        <a:srgbClr val="E5E7EB"/>
+                      </a:solidFill>
+                      <a:prstDash val="solid"/>
+                      <a:round/>
+                      <a:headEnd type="none" w="med" len="med"/>
+                      <a:tailEnd type="none" w="med" len="med"/>
+                    </a:lnT>
+                    <a:lnB w="6350" cap="flat" cmpd="sng" algn="ctr">
+                      <a:solidFill>
+                        <a:srgbClr val="E5E7EB"/>
+                      </a:solidFill>
+                      <a:prstDash val="solid"/>
+                      <a:round/>
+                      <a:headEnd type="none" w="med" len="med"/>
+                      <a:tailEnd type="none" w="med" len="med"/>
+                    </a:lnB>
+                    <a:solidFill>
+                      <a:srgbClr val="FFFFFF"/>
+                    </a:solidFill>
+                  </a:tcPr>
+                </a:tc>
+              </a:tr>
+              <a:tr h="301752">
+                <a:tc>
+                  <a:txBody>
+                    <a:bodyPr/>
+                    <a:lstStyle/>
+                    <a:p>
+                      <a:pPr algn="l" indent="0" marL="0">
+                        <a:buNone/>
+                      </a:pPr>
+                      <a:r>
+                        <a:rPr lang="en-US" sz="1150" dirty="0">
+                          <a:solidFill>
+                            <a:srgbClr val="1F2937"/>
+                          </a:solidFill>
+                          <a:latin typeface="Calibri" pitchFamily="34" charset="0"/>
+                          <a:ea typeface="Calibri" pitchFamily="34" charset="-122"/>
+                          <a:cs typeface="Calibri" pitchFamily="34" charset="-120"/>
+                        </a:rPr>
+                        <a:t>Wireless Earbuds</a:t>
+                      </a:r>
+                      <a:endParaRPr lang="en-US" sz="1150" dirty="0">
+                        <a:latin typeface="Calibri" charset="0"/>
+                        <a:ea typeface="Calibri" charset="0"/>
+                        <a:cs typeface="Calibri" charset="0"/>
+                      </a:endParaRPr>
+                    </a:p>
+                  </a:txBody>
+                  <a:tcPr marL="45720" marR="45720" marT="45720" marB="45720">
+                    <a:lnL w="6350" cap="flat" cmpd="sng" algn="ctr">
+                      <a:solidFill>
+                        <a:srgbClr val="E5E7EB"/>
+                      </a:solidFill>
+                      <a:prstDash val="solid"/>
+                      <a:round/>
+                      <a:headEnd type="none" w="med" len="med"/>
+                      <a:tailEnd type="none" w="med" len="med"/>
+                    </a:lnL>
+                    <a:lnR w="6350" cap="flat" cmpd="sng" algn="ctr">
+                      <a:solidFill>
+                        <a:srgbClr val="E5E7EB"/>
+                      </a:solidFill>
+                      <a:prstDash val="solid"/>
+                      <a:round/>
+                      <a:headEnd type="none" w="med" len="med"/>
+                      <a:tailEnd type="none" w="med" len="med"/>
+                    </a:lnR>
+                    <a:lnT w="6350" cap="flat" cmpd="sng" algn="ctr">
+                      <a:solidFill>
+                        <a:srgbClr val="E5E7EB"/>
+                      </a:solidFill>
+                      <a:prstDash val="solid"/>
+                      <a:round/>
+                      <a:headEnd type="none" w="med" len="med"/>
+                      <a:tailEnd type="none" w="med" len="med"/>
+                    </a:lnT>
+                    <a:lnB w="6350" cap="flat" cmpd="sng" algn="ctr">
+                      <a:solidFill>
+                        <a:srgbClr val="E5E7EB"/>
+                      </a:solidFill>
+                      <a:prstDash val="solid"/>
+                      <a:round/>
+                      <a:headEnd type="none" w="med" len="med"/>
+                      <a:tailEnd type="none" w="med" len="med"/>
+                    </a:lnB>
+                    <a:solidFill>
+                      <a:srgbClr val="F3F6FC"/>
+                    </a:solidFill>
+                  </a:tcPr>
+                </a:tc>
+                <a:tc>
+                  <a:txBody>
+                    <a:bodyPr/>
+                    <a:lstStyle/>
+                    <a:p>
+                      <a:pPr algn="ctr" indent="0" marL="0">
+                        <a:buNone/>
+                      </a:pPr>
+                      <a:r>
+                        <a:rPr lang="en-US" sz="1150" dirty="0">
+                          <a:solidFill>
+                            <a:srgbClr val="1F2937"/>
+                          </a:solidFill>
+                          <a:latin typeface="Calibri" pitchFamily="34" charset="0"/>
+                          <a:ea typeface="Calibri" pitchFamily="34" charset="-122"/>
+                          <a:cs typeface="Calibri" pitchFamily="34" charset="-120"/>
+                        </a:rPr>
+                        <a:t>128</a:t>
+                      </a:r>
+                      <a:endParaRPr lang="en-US" sz="1150" dirty="0">
+                        <a:latin typeface="Calibri" charset="0"/>
+                        <a:ea typeface="Calibri" charset="0"/>
+                        <a:cs typeface="Calibri" charset="0"/>
+                      </a:endParaRPr>
+                    </a:p>
+                  </a:txBody>
+                  <a:tcPr marL="45720" marR="45720" marT="45720" marB="45720">
+                    <a:lnL w="6350" cap="flat" cmpd="sng" algn="ctr">
+                      <a:solidFill>
+                        <a:srgbClr val="E5E7EB"/>
+                      </a:solidFill>
+                      <a:prstDash val="solid"/>
+                      <a:round/>
+                      <a:headEnd type="none" w="med" len="med"/>
+                      <a:tailEnd type="none" w="med" len="med"/>
+                    </a:lnL>
+                    <a:lnR w="6350" cap="flat" cmpd="sng" algn="ctr">
+                      <a:solidFill>
+                        <a:srgbClr val="E5E7EB"/>
+                      </a:solidFill>
+                      <a:prstDash val="solid"/>
+                      <a:round/>
+                      <a:headEnd type="none" w="med" len="med"/>
+                      <a:tailEnd type="none" w="med" len="med"/>
+                    </a:lnR>
+                    <a:lnT w="6350" cap="flat" cmpd="sng" algn="ctr">
+                      <a:solidFill>
+                        <a:srgbClr val="E5E7EB"/>
+                      </a:solidFill>
+                      <a:prstDash val="solid"/>
+                      <a:round/>
+                      <a:headEnd type="none" w="med" len="med"/>
+                      <a:tailEnd type="none" w="med" len="med"/>
+                    </a:lnT>
+                    <a:lnB w="6350" cap="flat" cmpd="sng" algn="ctr">
+                      <a:solidFill>
+                        <a:srgbClr val="E5E7EB"/>
+                      </a:solidFill>
+                      <a:prstDash val="solid"/>
+                      <a:round/>
+                      <a:headEnd type="none" w="med" len="med"/>
+                      <a:tailEnd type="none" w="med" len="med"/>
+                    </a:lnB>
+                    <a:solidFill>
+                      <a:srgbClr val="F3F6FC"/>
+                    </a:solidFill>
+                  </a:tcPr>
+                </a:tc>
+                <a:tc>
+                  <a:txBody>
+                    <a:bodyPr/>
+                    <a:lstStyle/>
+                    <a:p>
+                      <a:pPr algn="ctr" indent="0" marL="0">
+                        <a:buNone/>
+                      </a:pPr>
+                      <a:r>
+                        <a:rPr lang="en-US" sz="1150" dirty="0">
+                          <a:solidFill>
+                            <a:srgbClr val="1F2937"/>
+                          </a:solidFill>
+                          <a:latin typeface="Calibri" pitchFamily="34" charset="0"/>
+                          <a:ea typeface="Calibri" pitchFamily="34" charset="-122"/>
+                          <a:cs typeface="Calibri" pitchFamily="34" charset="-120"/>
+                        </a:rPr>
+                        <a:t>$7.2k</a:t>
+                      </a:r>
+                      <a:endParaRPr lang="en-US" sz="1150" dirty="0">
+                        <a:latin typeface="Calibri" charset="0"/>
+                        <a:ea typeface="Calibri" charset="0"/>
+                        <a:cs typeface="Calibri" charset="0"/>
+                      </a:endParaRPr>
+                    </a:p>
+                  </a:txBody>
+                  <a:tcPr marL="45720" marR="45720" marT="45720" marB="45720">
+                    <a:lnL w="6350" cap="flat" cmpd="sng" algn="ctr">
+                      <a:solidFill>
+                        <a:srgbClr val="E5E7EB"/>
+                      </a:solidFill>
+                      <a:prstDash val="solid"/>
+                      <a:round/>
+                      <a:headEnd type="none" w="med" len="med"/>
+                      <a:tailEnd type="none" w="med" len="med"/>
+                    </a:lnL>
+                    <a:lnR w="6350" cap="flat" cmpd="sng" algn="ctr">
+                      <a:solidFill>
+                        <a:srgbClr val="E5E7EB"/>
+                      </a:solidFill>
+                      <a:prstDash val="solid"/>
+                      <a:round/>
+                      <a:headEnd type="none" w="med" len="med"/>
+                      <a:tailEnd type="none" w="med" len="med"/>
+                    </a:lnR>
+                    <a:lnT w="6350" cap="flat" cmpd="sng" algn="ctr">
+                      <a:solidFill>
+                        <a:srgbClr val="E5E7EB"/>
+                      </a:solidFill>
+                      <a:prstDash val="solid"/>
+                      <a:round/>
+                      <a:headEnd type="none" w="med" len="med"/>
+                      <a:tailEnd type="none" w="med" len="med"/>
+                    </a:lnT>
+                    <a:lnB w="6350" cap="flat" cmpd="sng" algn="ctr">
+                      <a:solidFill>
+                        <a:srgbClr val="E5E7EB"/>
+                      </a:solidFill>
+                      <a:prstDash val="solid"/>
+                      <a:round/>
+                      <a:headEnd type="none" w="med" len="med"/>
+                      <a:tailEnd type="none" w="med" len="med"/>
+                    </a:lnB>
+                    <a:solidFill>
+                      <a:srgbClr val="F3F6FC"/>
+                    </a:solidFill>
+                  </a:tcPr>
+                </a:tc>
+              </a:tr>
+              <a:tr h="301752">
+                <a:tc>
+                  <a:txBody>
+                    <a:bodyPr/>
+                    <a:lstStyle/>
+                    <a:p>
+                      <a:pPr algn="l" indent="0" marL="0">
+                        <a:buNone/>
+                      </a:pPr>
+                      <a:r>
+                        <a:rPr lang="en-US" sz="1150" dirty="0">
+                          <a:solidFill>
+                            <a:srgbClr val="1F2937"/>
+                          </a:solidFill>
+                          <a:latin typeface="Calibri" pitchFamily="34" charset="0"/>
+                          <a:ea typeface="Calibri" pitchFamily="34" charset="-122"/>
+                          <a:cs typeface="Calibri" pitchFamily="34" charset="-120"/>
+                        </a:rPr>
+                        <a:t>Smartwatch</a:t>
+                      </a:r>
+                      <a:endParaRPr lang="en-US" sz="1150" dirty="0">
+                        <a:latin typeface="Calibri" charset="0"/>
+                        <a:ea typeface="Calibri" charset="0"/>
+                        <a:cs typeface="Calibri" charset="0"/>
+                      </a:endParaRPr>
+                    </a:p>
+                  </a:txBody>
+                  <a:tcPr marL="45720" marR="45720" marT="45720" marB="45720">
+                    <a:lnL w="6350" cap="flat" cmpd="sng" algn="ctr">
+                      <a:solidFill>
+                        <a:srgbClr val="E5E7EB"/>
+                      </a:solidFill>
+                      <a:prstDash val="solid"/>
+                      <a:round/>
+                      <a:headEnd type="none" w="med" len="med"/>
+                      <a:tailEnd type="none" w="med" len="med"/>
+                    </a:lnL>
+                    <a:lnR w="6350" cap="flat" cmpd="sng" algn="ctr">
+                      <a:solidFill>
+                        <a:srgbClr val="E5E7EB"/>
+                      </a:solidFill>
+                      <a:prstDash val="solid"/>
+                      <a:round/>
+                      <a:headEnd type="none" w="med" len="med"/>
+                      <a:tailEnd type="none" w="med" len="med"/>
+                    </a:lnR>
+                    <a:lnT w="6350" cap="flat" cmpd="sng" algn="ctr">
+                      <a:solidFill>
+                        <a:srgbClr val="E5E7EB"/>
+                      </a:solidFill>
+                      <a:prstDash val="solid"/>
+                      <a:round/>
+                      <a:headEnd type="none" w="med" len="med"/>
+                      <a:tailEnd type="none" w="med" len="med"/>
+                    </a:lnT>
+                    <a:lnB w="6350" cap="flat" cmpd="sng" algn="ctr">
+                      <a:solidFill>
+                        <a:srgbClr val="E5E7EB"/>
+                      </a:solidFill>
+                      <a:prstDash val="solid"/>
+                      <a:round/>
+                      <a:headEnd type="none" w="med" len="med"/>
+                      <a:tailEnd type="none" w="med" len="med"/>
+                    </a:lnB>
+                    <a:solidFill>
+                      <a:srgbClr val="FFFFFF"/>
+                    </a:solidFill>
+                  </a:tcPr>
+                </a:tc>
+                <a:tc>
+                  <a:txBody>
+                    <a:bodyPr/>
+                    <a:lstStyle/>
+                    <a:p>
+                      <a:pPr algn="ctr" indent="0" marL="0">
+                        <a:buNone/>
+                      </a:pPr>
+                      <a:r>
+                        <a:rPr lang="en-US" sz="1150" dirty="0">
+                          <a:solidFill>
+                            <a:srgbClr val="1F2937"/>
+                          </a:solidFill>
+                          <a:latin typeface="Calibri" pitchFamily="34" charset="0"/>
+                          <a:ea typeface="Calibri" pitchFamily="34" charset="-122"/>
+                          <a:cs typeface="Calibri" pitchFamily="34" charset="-120"/>
+                        </a:rPr>
+                        <a:t>55</a:t>
+                      </a:r>
+                      <a:endParaRPr lang="en-US" sz="1150" dirty="0">
+                        <a:latin typeface="Calibri" charset="0"/>
+                        <a:ea typeface="Calibri" charset="0"/>
+                        <a:cs typeface="Calibri" charset="0"/>
+                      </a:endParaRPr>
+                    </a:p>
+                  </a:txBody>
+                  <a:tcPr marL="45720" marR="45720" marT="45720" marB="45720">
+                    <a:lnL w="6350" cap="flat" cmpd="sng" algn="ctr">
+                      <a:solidFill>
+                        <a:srgbClr val="E5E7EB"/>
+                      </a:solidFill>
+                      <a:prstDash val="solid"/>
+                      <a:round/>
+                      <a:headEnd type="none" w="med" len="med"/>
+                      <a:tailEnd type="none" w="med" len="med"/>
+                    </a:lnL>
+                    <a:lnR w="6350" cap="flat" cmpd="sng" algn="ctr">
+                      <a:solidFill>
+                        <a:srgbClr val="E5E7EB"/>
+                      </a:solidFill>
+                      <a:prstDash val="solid"/>
+                      <a:round/>
+                      <a:headEnd type="none" w="med" len="med"/>
+                      <a:tailEnd type="none" w="med" len="med"/>
+                    </a:lnR>
+                    <a:lnT w="6350" cap="flat" cmpd="sng" algn="ctr">
+                      <a:solidFill>
+                        <a:srgbClr val="E5E7EB"/>
+                      </a:solidFill>
+                      <a:prstDash val="solid"/>
+                      <a:round/>
+                      <a:headEnd type="none" w="med" len="med"/>
+                      <a:tailEnd type="none" w="med" len="med"/>
+                    </a:lnT>
+                    <a:lnB w="6350" cap="flat" cmpd="sng" algn="ctr">
+                      <a:solidFill>
+                        <a:srgbClr val="E5E7EB"/>
+                      </a:solidFill>
+                      <a:prstDash val="solid"/>
+                      <a:round/>
+                      <a:headEnd type="none" w="med" len="med"/>
+                      <a:tailEnd type="none" w="med" len="med"/>
+                    </a:lnB>
+                    <a:solidFill>
+                      <a:srgbClr val="FFFFFF"/>
+                    </a:solidFill>
+                  </a:tcPr>
+                </a:tc>
+                <a:tc>
+                  <a:txBody>
+                    <a:bodyPr/>
+                    <a:lstStyle/>
+                    <a:p>
+                      <a:pPr algn="ctr" indent="0" marL="0">
+                        <a:buNone/>
+                      </a:pPr>
+                      <a:r>
+                        <a:rPr lang="en-US" sz="1150" dirty="0">
+                          <a:solidFill>
+                            <a:srgbClr val="1F2937"/>
+                          </a:solidFill>
+                          <a:latin typeface="Calibri" pitchFamily="34" charset="0"/>
+                          <a:ea typeface="Calibri" pitchFamily="34" charset="-122"/>
+                          <a:cs typeface="Calibri" pitchFamily="34" charset="-120"/>
+                        </a:rPr>
+                        <a:t>$6.6k</a:t>
+                      </a:r>
+                      <a:endParaRPr lang="en-US" sz="1150" dirty="0">
+                        <a:latin typeface="Calibri" charset="0"/>
+                        <a:ea typeface="Calibri" charset="0"/>
+                        <a:cs typeface="Calibri" charset="0"/>
+                      </a:endParaRPr>
+                    </a:p>
+                  </a:txBody>
+                  <a:tcPr marL="45720" marR="45720" marT="45720" marB="45720">
+                    <a:lnL w="6350" cap="flat" cmpd="sng" algn="ctr">
+                      <a:solidFill>
+                        <a:srgbClr val="E5E7EB"/>
+                      </a:solidFill>
+                      <a:prstDash val="solid"/>
+                      <a:round/>
+                      <a:headEnd type="none" w="med" len="med"/>
+                      <a:tailEnd type="none" w="med" len="med"/>
+                    </a:lnL>
+                    <a:lnR w="6350" cap="flat" cmpd="sng" algn="ctr">
+                      <a:solidFill>
+                        <a:srgbClr val="E5E7EB"/>
+                      </a:solidFill>
+                      <a:prstDash val="solid"/>
+                      <a:round/>
+                      <a:headEnd type="none" w="med" len="med"/>
+                      <a:tailEnd type="none" w="med" len="med"/>
+                    </a:lnR>
+                    <a:lnT w="6350" cap="flat" cmpd="sng" algn="ctr">
+                      <a:solidFill>
+                        <a:srgbClr val="E5E7EB"/>
+                      </a:solidFill>
+                      <a:prstDash val="solid"/>
+                      <a:round/>
+                      <a:headEnd type="none" w="med" len="med"/>
+                      <a:tailEnd type="none" w="med" len="med"/>
+                    </a:lnT>
+                    <a:lnB w="6350" cap="flat" cmpd="sng" algn="ctr">
+                      <a:solidFill>
+                        <a:srgbClr val="E5E7EB"/>
+                      </a:solidFill>
+                      <a:prstDash val="solid"/>
+                      <a:round/>
+                      <a:headEnd type="none" w="med" len="med"/>
+                      <a:tailEnd type="none" w="med" len="med"/>
+                    </a:lnB>
+                    <a:solidFill>
+                      <a:srgbClr val="FFFFFF"/>
+                    </a:solidFill>
+                  </a:tcPr>
+                </a:tc>
+              </a:tr>
+              <a:tr h="301752">
+                <a:tc>
+                  <a:txBody>
+                    <a:bodyPr/>
+                    <a:lstStyle/>
+                    <a:p>
+                      <a:pPr algn="l" indent="0" marL="0">
+                        <a:buNone/>
+                      </a:pPr>
+                      <a:r>
+                        <a:rPr lang="en-US" sz="1150" dirty="0">
+                          <a:solidFill>
+                            <a:srgbClr val="1F2937"/>
+                          </a:solidFill>
+                          <a:latin typeface="Calibri" pitchFamily="34" charset="0"/>
+                          <a:ea typeface="Calibri" pitchFamily="34" charset="-122"/>
+                          <a:cs typeface="Calibri" pitchFamily="34" charset="-120"/>
+                        </a:rPr>
+                        <a:t>Noise-Cancelling Headphones</a:t>
+                      </a:r>
+                      <a:endParaRPr lang="en-US" sz="1150" dirty="0">
+                        <a:latin typeface="Calibri" charset="0"/>
+                        <a:ea typeface="Calibri" charset="0"/>
+                        <a:cs typeface="Calibri" charset="0"/>
+                      </a:endParaRPr>
+                    </a:p>
+                  </a:txBody>
+                  <a:tcPr marL="45720" marR="45720" marT="45720" marB="45720">
+                    <a:lnL w="6350" cap="flat" cmpd="sng" algn="ctr">
+                      <a:solidFill>
+                        <a:srgbClr val="E5E7EB"/>
+                      </a:solidFill>
+                      <a:prstDash val="solid"/>
+                      <a:round/>
+                      <a:headEnd type="none" w="med" len="med"/>
+                      <a:tailEnd type="none" w="med" len="med"/>
+                    </a:lnL>
+                    <a:lnR w="6350" cap="flat" cmpd="sng" algn="ctr">
+                      <a:solidFill>
+                        <a:srgbClr val="E5E7EB"/>
+                      </a:solidFill>
+                      <a:prstDash val="solid"/>
+                      <a:round/>
+                      <a:headEnd type="none" w="med" len="med"/>
+                      <a:tailEnd type="none" w="med" len="med"/>
+                    </a:lnR>
+                    <a:lnT w="6350" cap="flat" cmpd="sng" algn="ctr">
+                      <a:solidFill>
+                        <a:srgbClr val="E5E7EB"/>
+                      </a:solidFill>
+                      <a:prstDash val="solid"/>
+                      <a:round/>
+                      <a:headEnd type="none" w="med" len="med"/>
+                      <a:tailEnd type="none" w="med" len="med"/>
+                    </a:lnT>
+                    <a:lnB w="6350" cap="flat" cmpd="sng" algn="ctr">
+                      <a:solidFill>
+                        <a:srgbClr val="E5E7EB"/>
+                      </a:solidFill>
+                      <a:prstDash val="solid"/>
+                      <a:round/>
+                      <a:headEnd type="none" w="med" len="med"/>
+                      <a:tailEnd type="none" w="med" len="med"/>
+                    </a:lnB>
+                    <a:solidFill>
+                      <a:srgbClr val="F3F6FC"/>
+                    </a:solidFill>
+                  </a:tcPr>
+                </a:tc>
+                <a:tc>
+                  <a:txBody>
+                    <a:bodyPr/>
+                    <a:lstStyle/>
+                    <a:p>
+                      <a:pPr algn="ctr" indent="0" marL="0">
+                        <a:buNone/>
+                      </a:pPr>
+                      <a:r>
+                        <a:rPr lang="en-US" sz="1150" dirty="0">
+                          <a:solidFill>
+                            <a:srgbClr val="1F2937"/>
+                          </a:solidFill>
+                          <a:latin typeface="Calibri" pitchFamily="34" charset="0"/>
+                          <a:ea typeface="Calibri" pitchFamily="34" charset="-122"/>
+                          <a:cs typeface="Calibri" pitchFamily="34" charset="-120"/>
+                        </a:rPr>
+                        <a:t>47</a:t>
+                      </a:r>
+                      <a:endParaRPr lang="en-US" sz="1150" dirty="0">
+                        <a:latin typeface="Calibri" charset="0"/>
+                        <a:ea typeface="Calibri" charset="0"/>
+                        <a:cs typeface="Calibri" charset="0"/>
+                      </a:endParaRPr>
+                    </a:p>
+                  </a:txBody>
+                  <a:tcPr marL="45720" marR="45720" marT="45720" marB="45720">
+                    <a:lnL w="6350" cap="flat" cmpd="sng" algn="ctr">
+                      <a:solidFill>
+                        <a:srgbClr val="E5E7EB"/>
+                      </a:solidFill>
+                      <a:prstDash val="solid"/>
+                      <a:round/>
+                      <a:headEnd type="none" w="med" len="med"/>
+                      <a:tailEnd type="none" w="med" len="med"/>
+                    </a:lnL>
+                    <a:lnR w="6350" cap="flat" cmpd="sng" algn="ctr">
+                      <a:solidFill>
+                        <a:srgbClr val="E5E7EB"/>
+                      </a:solidFill>
+                      <a:prstDash val="solid"/>
+                      <a:round/>
+                      <a:headEnd type="none" w="med" len="med"/>
+                      <a:tailEnd type="none" w="med" len="med"/>
+                    </a:lnR>
+                    <a:lnT w="6350" cap="flat" cmpd="sng" algn="ctr">
+                      <a:solidFill>
+                        <a:srgbClr val="E5E7EB"/>
+                      </a:solidFill>
+                      <a:prstDash val="solid"/>
+                      <a:round/>
+                      <a:headEnd type="none" w="med" len="med"/>
+                      <a:tailEnd type="none" w="med" len="med"/>
+                    </a:lnT>
+                    <a:lnB w="6350" cap="flat" cmpd="sng" algn="ctr">
+                      <a:solidFill>
+                        <a:srgbClr val="E5E7EB"/>
+                      </a:solidFill>
+                      <a:prstDash val="solid"/>
+                      <a:round/>
+                      <a:headEnd type="none" w="med" len="med"/>
+                      <a:tailEnd type="none" w="med" len="med"/>
+                    </a:lnB>
+                    <a:solidFill>
+                      <a:srgbClr val="F3F6FC"/>
+                    </a:solidFill>
+                  </a:tcPr>
+                </a:tc>
+                <a:tc>
+                  <a:txBody>
+                    <a:bodyPr/>
+                    <a:lstStyle/>
+                    <a:p>
+                      <a:pPr algn="ctr" indent="0" marL="0">
+                        <a:buNone/>
+                      </a:pPr>
+                      <a:r>
+                        <a:rPr lang="en-US" sz="1150" dirty="0">
+                          <a:solidFill>
+                            <a:srgbClr val="1F2937"/>
+                          </a:solidFill>
+                          <a:latin typeface="Calibri" pitchFamily="34" charset="0"/>
+                          <a:ea typeface="Calibri" pitchFamily="34" charset="-122"/>
+                          <a:cs typeface="Calibri" pitchFamily="34" charset="-120"/>
+                        </a:rPr>
+                        <a:t>$6.5k</a:t>
+                      </a:r>
+                      <a:endParaRPr lang="en-US" sz="1150" dirty="0">
+                        <a:latin typeface="Calibri" charset="0"/>
+                        <a:ea typeface="Calibri" charset="0"/>
+                        <a:cs typeface="Calibri" charset="0"/>
+                      </a:endParaRPr>
+                    </a:p>
+                  </a:txBody>
+                  <a:tcPr marL="45720" marR="45720" marT="45720" marB="45720">
+                    <a:lnL w="6350" cap="flat" cmpd="sng" algn="ctr">
+                      <a:solidFill>
+                        <a:srgbClr val="E5E7EB"/>
+                      </a:solidFill>
+                      <a:prstDash val="solid"/>
+                      <a:round/>
+                      <a:headEnd type="none" w="med" len="med"/>
+                      <a:tailEnd type="none" w="med" len="med"/>
+                    </a:lnL>
+                    <a:lnR w="6350" cap="flat" cmpd="sng" algn="ctr">
+                      <a:solidFill>
+                        <a:srgbClr val="E5E7EB"/>
+                      </a:solidFill>
+                      <a:prstDash val="solid"/>
+                      <a:round/>
+                      <a:headEnd type="none" w="med" len="med"/>
+                      <a:tailEnd type="none" w="med" len="med"/>
+                    </a:lnR>
+                    <a:lnT w="6350" cap="flat" cmpd="sng" algn="ctr">
+                      <a:solidFill>
+                        <a:srgbClr val="E5E7EB"/>
+                      </a:solidFill>
+                      <a:prstDash val="solid"/>
+                      <a:round/>
+                      <a:headEnd type="none" w="med" len="med"/>
+                      <a:tailEnd type="none" w="med" len="med"/>
+                    </a:lnT>
+                    <a:lnB w="6350" cap="flat" cmpd="sng" algn="ctr">
+                      <a:solidFill>
+                        <a:srgbClr val="E5E7EB"/>
+                      </a:solidFill>
+                      <a:prstDash val="solid"/>
+                      <a:round/>
+                      <a:headEnd type="none" w="med" len="med"/>
+                      <a:tailEnd type="none" w="med" len="med"/>
+                    </a:lnB>
+                    <a:solidFill>
+                      <a:srgbClr val="F3F6FC"/>
+                    </a:solidFill>
+                  </a:tcPr>
+                </a:tc>
+              </a:tr>
+            </a:tbl>
+          </a:graphicData>
+        </a:graphic>
+      </p:graphicFrame>
+      <p:sp>
+        <p:nvSpPr>
+          <p:cNvPr id="6" name="Shape 2"/>
+          <p:cNvSpPr/>
+          <p:nvPr/>
+        </p:nvSpPr>
+        <p:spPr>
+          <a:xfrm>
+            <a:off x="7406640" y="3840480"/>
+            <a:ext cx="4206240" cy="2331720"/>
+          </a:xfrm>
+          <a:prstGeom prst="roundRect">
+            <a:avLst>
+              <a:gd name="adj" fmla="val 4706"/>
+            </a:avLst>
+          </a:prstGeom>
+          <a:solidFill>
+            <a:srgbClr val="EEF4FF"/>
+          </a:solidFill>
+          <a:ln w="12700">
+            <a:solidFill>
+              <a:srgbClr val="EEF4FF"/>
+            </a:solidFill>
+            <a:prstDash val="solid"/>
+          </a:ln>
+        </p:spPr>
+        <p:txBody>
+          <a:bodyPr/>
+          <a:p/>
+        </p:txBody>
+      </p:sp>
+      <p:sp>
+        <p:nvSpPr>
+          <p:cNvPr id="7" name="Text 3"/>
+          <p:cNvSpPr txBox="1"/>
+          <p:nvPr/>
+        </p:nvSpPr>
+        <p:spPr>
+          <a:xfrm>
+            <a:off x="7589520" y="3931920"/>
+            <a:ext cx="3840480" cy="2148840"/>
+          </a:xfrm>
+          <a:prstGeom prst="rect">
+            <a:avLst/>
+          </a:prstGeom>
+          <a:noFill/>
+          <a:ln/>
+        </p:spPr>
+        <p:txBody>
+          <a:bodyPr wrap="square" lIns="0" tIns="0" rIns="0" bIns="0" rtlCol="0" anchor="t"/>
+          <a:lstStyle/>
+          <a:p>
+            <a:pPr indent="0" marL="0">
+              <a:buNone/>
+            </a:pPr>
+            <a:r>
+              <a:rPr lang="en-US" sz="1250" b="1" dirty="0">
+                <a:solidFill>
+                  <a:srgbClr val="1E2761"/>
+                </a:solidFill>
+                <a:latin typeface="Calibri" pitchFamily="34" charset="0"/>
+                <a:ea typeface="Calibri" pitchFamily="34" charset="-122"/>
+                <a:cs typeface="Calibri" pitchFamily="34" charset="-120"/>
+              </a:rPr>
+              <a:t>Interpretation  </a:t>
+            </a:r>
+            <a:pPr indent="0" marL="0">
+              <a:buNone/>
+            </a:pPr>
+            <a:r>
+              <a:rPr lang="en-US" sz="1250" dirty="0">
+                <a:solidFill>
+                  <a:srgbClr val="1F2937"/>
+                </a:solidFill>
+                <a:latin typeface="Calibri" pitchFamily="34" charset="0"/>
+                <a:ea typeface="Calibri" pitchFamily="34" charset="-122"/>
+                <a:cs typeface="Calibri" pitchFamily="34" charset="-120"/>
+              </a:rPr>
+              <a:t>The Smartphone A54 alone earns 11 % of net revenue and the top 10 of 60 products earn 51 %. The 4L Air Fryer is the best non-Electronics product (Small Appliances = 60 % of Home &amp; Kitchen). Stock cover = stock ÷ average monthly units: Noise-Cancelling Headphones and LED Table Lamp are sold out; 4 more are at or below their reorder level.</a:t>
+            </a:r>
+            <a:endParaRPr lang="en-US" sz="1250" dirty="0"/>
+          </a:p>
+        </p:txBody>
+      </p:sp>
+      <p:pic>
+        <p:nvPicPr>
+          <p:cNvPr id="10" name="Picture 9" descr="10_top_products.png"/>
+          <p:cNvPicPr>
+            <a:picLocks noChangeAspect="1"/>
+          </p:cNvPicPr>
+          <p:nvPr/>
+        </p:nvPicPr>
+        <p:blipFill>
+          <a:blip r:embed="rId2"/>
+          <a:stretch>
+            <a:fillRect/>
+          </a:stretch>
+        </p:blipFill>
+        <p:spPr>
+          <a:xfrm>
+            <a:off x="548640" y="1534440"/>
+            <a:ext cx="6583680" cy="3892009"/>
+          </a:xfrm>
+          <a:prstGeom prst="rect">
+            <a:avLst/>
+          </a:prstGeom>
+        </p:spPr>
+      </p:pic>
+    </p:spTree>
+  </p:cSld>
+  <p:clrMapOvr>
+    <a:masterClrMapping/>
+  </p:clrMapOvr>
+</p:sld>
+</file>
+
+<file path=ppt/slides/slide14.xml><?xml version="1.0" encoding="utf-8"?>
 <p:sld xmlns:a="http://schemas.openxmlformats.org/drawingml/2006/main" xmlns:r="http://schemas.openxmlformats.org/officeDocument/2006/relationships" xmlns:p="http://schemas.openxmlformats.org/presentationml/2006/main">
   <p:cSld name="Slide 13">
     <p:bg>
@@ -6368,7 +8258,7 @@
                 <a:ea typeface="Calibri" pitchFamily="34" charset="-122"/>
                 <a:cs typeface="Calibri" pitchFamily="34" charset="-120"/>
               </a:rPr>
-              <a:t>E-commerce Customer Analytics  ·  13</a:t>
+              <a:t>E-commerce Customer Analytics  ·  14</a:t>
             </a:r>
             <a:endParaRPr lang="en-US" sz="1000" dirty="0"/>
           </a:p>
@@ -7038,7 +8928,7 @@
                           <a:ea typeface="Calibri" pitchFamily="34" charset="-122"/>
                           <a:cs typeface="Calibri" pitchFamily="34" charset="-120"/>
                         </a:rPr>
-                        <a:t>136.47</a:t>
+                        <a:t>91.90</a:t>
                       </a:r>
                       <a:endParaRPr lang="en-US" sz="1150" dirty="0">
                         <a:latin typeface="Calibri" charset="0"/>
@@ -7106,7 +8996,7 @@
                           <a:ea typeface="Calibri" pitchFamily="34" charset="-122"/>
                           <a:cs typeface="Calibri" pitchFamily="34" charset="-120"/>
                         </a:rPr>
-                        <a:t>75.73</a:t>
+                        <a:t>49.54</a:t>
                       </a:r>
                       <a:endParaRPr lang="en-US" sz="1150" dirty="0">
                         <a:latin typeface="Calibri" charset="0"/>
@@ -7174,7 +9064,7 @@
                           <a:ea typeface="Calibri" pitchFamily="34" charset="-122"/>
                           <a:cs typeface="Calibri" pitchFamily="34" charset="-120"/>
                         </a:rPr>
-                        <a:t>12.99</a:t>
+                        <a:t>31.99</a:t>
                       </a:r>
                       <a:endParaRPr lang="en-US" sz="1150" dirty="0">
                         <a:latin typeface="Calibri" charset="0"/>
@@ -7242,7 +9132,7 @@
                           <a:ea typeface="Calibri" pitchFamily="34" charset="-122"/>
                           <a:cs typeface="Calibri" pitchFamily="34" charset="-120"/>
                         </a:rPr>
-                        <a:t>5.24</a:t>
+                        <a:t>9.29</a:t>
                       </a:r>
                       <a:endParaRPr lang="en-US" sz="1150" dirty="0">
                         <a:latin typeface="Calibri" charset="0"/>
@@ -7310,7 +9200,7 @@
                           <a:ea typeface="Calibri" pitchFamily="34" charset="-122"/>
                           <a:cs typeface="Calibri" pitchFamily="34" charset="-120"/>
                         </a:rPr>
-                        <a:t>1,773.79</a:t>
+                        <a:t>1,849.65</a:t>
                       </a:r>
                       <a:endParaRPr lang="en-US" sz="1150" dirty="0">
                         <a:latin typeface="Calibri" charset="0"/>
@@ -7378,7 +9268,7 @@
                           <a:ea typeface="Calibri" pitchFamily="34" charset="-122"/>
                           <a:cs typeface="Calibri" pitchFamily="34" charset="-120"/>
                         </a:rPr>
-                        <a:t>177.62</a:t>
+                        <a:t>142.75</a:t>
                       </a:r>
                       <a:endParaRPr lang="en-US" sz="1150" dirty="0">
                         <a:latin typeface="Calibri" charset="0"/>
@@ -7446,7 +9336,7 @@
                           <a:ea typeface="Calibri" pitchFamily="34" charset="-122"/>
                           <a:cs typeface="Calibri" pitchFamily="34" charset="-120"/>
                         </a:rPr>
-                        <a:t>31,549</a:t>
+                        <a:t>20,377.32</a:t>
                       </a:r>
                       <a:endParaRPr lang="en-US" sz="1150" dirty="0">
                         <a:latin typeface="Calibri" charset="0"/>
@@ -8130,7 +10020,7 @@
                           <a:ea typeface="Calibri" pitchFamily="34" charset="-122"/>
                           <a:cs typeface="Calibri" pitchFamily="34" charset="-120"/>
                         </a:rPr>
-                        <a:t>5.96</a:t>
+                        <a:t>5.93</a:t>
                       </a:r>
                       <a:endParaRPr lang="en-US" sz="1150" dirty="0">
                         <a:latin typeface="Calibri" charset="0"/>
@@ -8266,7 +10156,7 @@
                           <a:ea typeface="Calibri" pitchFamily="34" charset="-122"/>
                           <a:cs typeface="Calibri" pitchFamily="34" charset="-120"/>
                         </a:rPr>
-                        <a:t>—</a:t>
+                        <a:t>5</a:t>
                       </a:r>
                       <a:endParaRPr lang="en-US" sz="1150" dirty="0">
                         <a:latin typeface="Calibri" charset="0"/>
@@ -8470,7 +10360,7 @@
                           <a:ea typeface="Calibri" pitchFamily="34" charset="-122"/>
                           <a:cs typeface="Calibri" pitchFamily="34" charset="-120"/>
                         </a:rPr>
-                        <a:t>3.16</a:t>
+                        <a:t>3.12</a:t>
                       </a:r>
                       <a:endParaRPr lang="en-US" sz="1150" dirty="0">
                         <a:latin typeface="Calibri" charset="0"/>
@@ -8538,7 +10428,7 @@
                           <a:ea typeface="Calibri" pitchFamily="34" charset="-122"/>
                           <a:cs typeface="Calibri" pitchFamily="34" charset="-120"/>
                         </a:rPr>
-                        <a:t>10.0</a:t>
+                        <a:t>9.73</a:t>
                       </a:r>
                       <a:endParaRPr lang="en-US" sz="1150" dirty="0">
                         <a:latin typeface="Calibri" charset="0"/>
@@ -8676,7 +10566,7 @@
                           <a:ea typeface="Calibri" pitchFamily="34" charset="-122"/>
                           <a:cs typeface="Calibri" pitchFamily="34" charset="-120"/>
                         </a:rPr>
-                        <a:t>3.55</a:t>
+                        <a:t>3.53</a:t>
                       </a:r>
                       <a:endParaRPr lang="en-US" sz="1150" dirty="0">
                         <a:latin typeface="Calibri" charset="0"/>
@@ -9016,7 +10906,7 @@
                           <a:ea typeface="Calibri" pitchFamily="34" charset="-122"/>
                           <a:cs typeface="Calibri" pitchFamily="34" charset="-120"/>
                         </a:rPr>
-                        <a:t>0.89</a:t>
+                        <a:t>0.91</a:t>
                       </a:r>
                       <a:endParaRPr lang="en-US" sz="1150" dirty="0">
                         <a:latin typeface="Calibri" charset="0"/>
@@ -9084,7 +10974,7 @@
                           <a:ea typeface="Calibri" pitchFamily="34" charset="-122"/>
                           <a:cs typeface="Calibri" pitchFamily="34" charset="-120"/>
                         </a:rPr>
-                        <a:t>0.80</a:t>
+                        <a:t>0.83</a:t>
                       </a:r>
                       <a:endParaRPr lang="en-US" sz="1150" dirty="0">
                         <a:latin typeface="Calibri" charset="0"/>
@@ -9222,7 +11112,7 @@
                           <a:ea typeface="Calibri" pitchFamily="34" charset="-122"/>
                           <a:cs typeface="Calibri" pitchFamily="34" charset="-120"/>
                         </a:rPr>
-                        <a:t>34.44</a:t>
+                        <a:t>34.42</a:t>
                       </a:r>
                       <a:endParaRPr lang="en-US" sz="1150" dirty="0">
                         <a:latin typeface="Calibri" charset="0"/>
@@ -9358,7 +11248,7 @@
                           <a:ea typeface="Calibri" pitchFamily="34" charset="-122"/>
                           <a:cs typeface="Calibri" pitchFamily="34" charset="-120"/>
                         </a:rPr>
-                        <a:t>34</a:t>
+                        <a:t>18</a:t>
                       </a:r>
                       <a:endParaRPr lang="en-US" sz="1150" dirty="0">
                         <a:latin typeface="Calibri" charset="0"/>
@@ -9562,7 +11452,7 @@
                           <a:ea typeface="Calibri" pitchFamily="34" charset="-122"/>
                           <a:cs typeface="Calibri" pitchFamily="34" charset="-120"/>
                         </a:rPr>
-                        <a:t>10.03</a:t>
+                        <a:t>10.04</a:t>
                       </a:r>
                       <a:endParaRPr lang="en-US" sz="1150" dirty="0">
                         <a:latin typeface="Calibri" charset="0"/>
@@ -9630,7 +11520,7 @@
                           <a:ea typeface="Calibri" pitchFamily="34" charset="-122"/>
                           <a:cs typeface="Calibri" pitchFamily="34" charset="-120"/>
                         </a:rPr>
-                        <a:t>100.66</a:t>
+                        <a:t>100.72</a:t>
                       </a:r>
                       <a:endParaRPr lang="en-US" sz="1150" dirty="0">
                         <a:latin typeface="Calibri" charset="0"/>
@@ -9712,6 +11602,10 @@
             <a:prstDash val="solid"/>
           </a:ln>
         </p:spPr>
+        <p:txBody>
+          <a:bodyPr/>
+          <a:p/>
+        </p:txBody>
       </p:sp>
       <p:sp>
         <p:nvSpPr>
@@ -9760,7 +11654,7 @@
                 <a:ea typeface="Calibri" pitchFamily="34" charset="-122"/>
                 <a:cs typeface="Calibri" pitchFamily="34" charset="-120"/>
               </a:rPr>
-              <a:t>Order value is right-skewed (skew 3.4): mean ≈ 2× median, std &gt; mean. Use the median as the 'typical order'. Ratings cluster at 4; age is symmetric around 34.</a:t>
+              <a:t>Order value is right-skewed (skew 5.6): mean ≈ 2× median, std &gt; mean. Use the median as the 'typical order'. Ratings cluster at 4; age is symmetric around 34.</a:t>
             </a:r>
             <a:endParaRPr lang="en-US" sz="1250" dirty="0"/>
           </a:p>
@@ -9814,6 +11708,10 @@
             <a:prstDash val="solid"/>
           </a:ln>
         </p:spPr>
+        <p:txBody>
+          <a:bodyPr/>
+          <a:p/>
+        </p:txBody>
       </p:sp>
       <p:sp>
         <p:nvSpPr>
@@ -9887,7 +11785,7 @@
                 <a:ea typeface="Calibri" pitchFamily="34" charset="-122"/>
                 <a:cs typeface="Calibri" pitchFamily="34" charset="-120"/>
               </a:rPr>
-              <a:t>r = −0.38, p ≈ 1e-42</a:t>
+              <a:t>r = −0.41, p ≈ 1e-50</a:t>
             </a:r>
             <a:endParaRPr lang="en-US" sz="1250" dirty="0"/>
           </a:p>
@@ -9917,6 +11815,10 @@
             <a:prstDash val="solid"/>
           </a:ln>
         </p:spPr>
+        <p:txBody>
+          <a:bodyPr/>
+          <a:p/>
+        </p:txBody>
       </p:sp>
       <p:sp>
         <p:nvSpPr>
@@ -9990,7 +11892,7 @@
                 <a:ea typeface="Calibri" pitchFamily="34" charset="-122"/>
                 <a:cs typeface="Calibri" pitchFamily="34" charset="-120"/>
               </a:rPr>
-              <a:t>ANOVA F = 63.8, p &lt; 0.001</a:t>
+              <a:t>ANOVA F = 75.0, p &lt; 0.001</a:t>
             </a:r>
             <a:endParaRPr lang="en-US" sz="1250" dirty="0"/>
           </a:p>
@@ -10020,6 +11922,10 @@
             <a:prstDash val="solid"/>
           </a:ln>
         </p:spPr>
+        <p:txBody>
+          <a:bodyPr/>
+          <a:p/>
+        </p:txBody>
       </p:sp>
       <p:sp>
         <p:nvSpPr>
@@ -10093,7 +11999,7 @@
                 <a:ea typeface="Calibri" pitchFamily="34" charset="-122"/>
                 <a:cs typeface="Calibri" pitchFamily="34" charset="-120"/>
               </a:rPr>
-              <a:t>t = −0.53, p = 0.60 — no difference</a:t>
+              <a:t>t = −1.14, p = 0.26 — no difference</a:t>
             </a:r>
             <a:endParaRPr lang="en-US" sz="1250" dirty="0"/>
           </a:p>
@@ -10123,6 +12029,10 @@
             <a:prstDash val="solid"/>
           </a:ln>
         </p:spPr>
+        <p:txBody>
+          <a:bodyPr/>
+          <a:p/>
+        </p:txBody>
       </p:sp>
       <p:sp>
         <p:nvSpPr>
@@ -10196,7 +12106,7 @@
                 <a:ea typeface="Calibri" pitchFamily="34" charset="-122"/>
                 <a:cs typeface="Calibri" pitchFamily="34" charset="-120"/>
               </a:rPr>
-              <a:t>χ² = 8.2, p = 0.23 — not significant</a:t>
+              <a:t>χ² = 15.8, p = 0.015 — significant</a:t>
             </a:r>
             <a:endParaRPr lang="en-US" sz="1250" dirty="0"/>
           </a:p>
@@ -10235,7 +12145,7 @@
                 <a:ea typeface="Calibri" pitchFamily="34" charset="-122"/>
                 <a:cs typeface="Calibri" pitchFamily="34" charset="-120"/>
               </a:rPr>
-              <a:t>Only delivery time shows a substantive, significant relationship with satisfaction; demographics and discounts have |r| &lt; 0.07 with spend.</a:t>
+              <a:t>Delivery time is the only behavioural variable with a substantive, significant link to satisfaction; returns differ by category (Fashion highest); demographics and discounts have |r| &lt; 0.07 with spend.</a:t>
             </a:r>
             <a:endParaRPr lang="en-US" sz="1250" dirty="0"/>
           </a:p>
@@ -10249,7 +12159,7 @@
 </p:sld>
 </file>
 
-<file path=ppt/slides/slide14.xml><?xml version="1.0" encoding="utf-8"?>
+<file path=ppt/slides/slide15.xml><?xml version="1.0" encoding="utf-8"?>
 <p:sld xmlns:a="http://schemas.openxmlformats.org/drawingml/2006/main" xmlns:r="http://schemas.openxmlformats.org/officeDocument/2006/relationships" xmlns:p="http://schemas.openxmlformats.org/presentationml/2006/main">
   <p:cSld name="Slide 14">
     <p:bg>
@@ -10345,7 +12255,7 @@
                 <a:ea typeface="Calibri" pitchFamily="34" charset="-122"/>
                 <a:cs typeface="Calibri" pitchFamily="34" charset="-120"/>
               </a:rPr>
-              <a:t>E-commerce Customer Analytics  ·  14</a:t>
+              <a:t>E-commerce Customer Analytics  ·  15</a:t>
             </a:r>
             <a:endParaRPr lang="en-US" sz="1000" dirty="0"/>
           </a:p>
@@ -10377,6 +12287,10 @@
             <a:prstDash val="solid"/>
           </a:ln>
         </p:spPr>
+        <p:txBody>
+          <a:bodyPr/>
+          <a:p/>
+        </p:txBody>
       </p:sp>
       <p:sp>
         <p:nvSpPr>
@@ -10411,7 +12325,7 @@
                 <a:ea typeface="Cambria" pitchFamily="34" charset="-122"/>
                 <a:cs typeface="Cambria" pitchFamily="34" charset="-120"/>
               </a:rPr>
-              <a:t>54 %</a:t>
+              <a:t>47 %</a:t>
             </a:r>
             <a:endParaRPr lang="en-US" sz="2600" dirty="0"/>
           </a:p>
@@ -10450,7 +12364,7 @@
                 <a:ea typeface="Calibri" pitchFamily="34" charset="-122"/>
                 <a:cs typeface="Calibri" pitchFamily="34" charset="-120"/>
               </a:rPr>
-              <a:t>of revenue from Electronics; top 3 categories ≈ 80 %</a:t>
+              <a:t>of revenue from Electronics; Smartphone A54 alone = 11 %</a:t>
             </a:r>
             <a:endParaRPr lang="en-US" sz="1350" dirty="0"/>
           </a:p>
@@ -10482,6 +12396,10 @@
             <a:prstDash val="solid"/>
           </a:ln>
         </p:spPr>
+        <p:txBody>
+          <a:bodyPr/>
+          <a:p/>
+        </p:txBody>
       </p:sp>
       <p:sp>
         <p:nvSpPr>
@@ -10516,7 +12434,7 @@
                 <a:ea typeface="Cambria" pitchFamily="34" charset="-122"/>
                 <a:cs typeface="Cambria" pitchFamily="34" charset="-120"/>
               </a:rPr>
-              <a:t>4.8 vs 1.6</a:t>
+              <a:t>4.9 vs 1.6</a:t>
             </a:r>
             <a:endParaRPr lang="en-US" sz="2600" dirty="0"/>
           </a:p>
@@ -10555,7 +12473,7 @@
                 <a:ea typeface="Calibri" pitchFamily="34" charset="-122"/>
                 <a:cs typeface="Calibri" pitchFamily="34" charset="-120"/>
               </a:rPr>
-              <a:t>orders per VIP vs New customer — same basket size (p = 0.60)</a:t>
+              <a:t>orders per VIP vs New customer — same basket size (p = 0.26)</a:t>
             </a:r>
             <a:endParaRPr lang="en-US" sz="1350" dirty="0"/>
           </a:p>
@@ -10587,6 +12505,10 @@
             <a:prstDash val="solid"/>
           </a:ln>
         </p:spPr>
+        <p:txBody>
+          <a:bodyPr/>
+          <a:p/>
+        </p:txBody>
       </p:sp>
       <p:sp>
         <p:nvSpPr>
@@ -10621,7 +12543,7 @@
                 <a:ea typeface="Cambria" pitchFamily="34" charset="-122"/>
                 <a:cs typeface="Cambria" pitchFamily="34" charset="-120"/>
               </a:rPr>
-              <a:t>−0.38</a:t>
+              <a:t>−0.41</a:t>
             </a:r>
             <a:endParaRPr lang="en-US" sz="2600" dirty="0"/>
           </a:p>
@@ -10660,7 +12582,7 @@
                 <a:ea typeface="Calibri" pitchFamily="34" charset="-122"/>
                 <a:cs typeface="Calibri" pitchFamily="34" charset="-120"/>
               </a:rPr>
-              <a:t>correlation of delivery days with rating; 3.96★ → 3.02★</a:t>
+              <a:t>correlation of delivery days with rating; 3.97★ → 3.00★</a:t>
             </a:r>
             <a:endParaRPr lang="en-US" sz="1350" dirty="0"/>
           </a:p>
@@ -10692,6 +12614,10 @@
             <a:prstDash val="solid"/>
           </a:ln>
         </p:spPr>
+        <p:txBody>
+          <a:bodyPr/>
+          <a:p/>
+        </p:txBody>
       </p:sp>
       <p:sp>
         <p:nvSpPr>
@@ -10726,7 +12652,7 @@
                 <a:ea typeface="Cambria" pitchFamily="34" charset="-122"/>
                 <a:cs typeface="Cambria" pitchFamily="34" charset="-120"/>
               </a:rPr>
-              <a:t>17 %</a:t>
+              <a:t>18 %</a:t>
             </a:r>
             <a:endParaRPr lang="en-US" sz="2600" dirty="0"/>
           </a:p>
@@ -10765,7 +12691,7 @@
                 <a:ea typeface="Calibri" pitchFamily="34" charset="-122"/>
                 <a:cs typeface="Calibri" pitchFamily="34" charset="-120"/>
               </a:rPr>
-              <a:t>of orders returned (10.8 %) or cancelled (6.6 %); Fashion returns 13.6 %</a:t>
+              <a:t>of orders returned (11.2 %) or cancelled (6.6 %); Fashion returns 15.7 %</a:t>
             </a:r>
             <a:endParaRPr lang="en-US" sz="1350" dirty="0"/>
           </a:p>
@@ -10797,6 +12723,10 @@
             <a:prstDash val="solid"/>
           </a:ln>
         </p:spPr>
+        <p:txBody>
+          <a:bodyPr/>
+          <a:p/>
+        </p:txBody>
       </p:sp>
       <p:sp>
         <p:nvSpPr>
@@ -10870,7 +12800,7 @@
                 <a:ea typeface="Calibri" pitchFamily="34" charset="-122"/>
                 <a:cs typeface="Calibri" pitchFamily="34" charset="-120"/>
               </a:rPr>
-              <a:t>December revenue vs Q1 average; January −63 % MoM</a:t>
+              <a:t>December revenue vs Q1 average; January −45 % MoM</a:t>
             </a:r>
             <a:endParaRPr lang="en-US" sz="1350" dirty="0"/>
           </a:p>
@@ -10902,6 +12832,10 @@
             <a:prstDash val="solid"/>
           </a:ln>
         </p:spPr>
+        <p:txBody>
+          <a:bodyPr/>
+          <a:p/>
+        </p:txBody>
       </p:sp>
       <p:sp>
         <p:nvSpPr>
@@ -11007,6 +12941,10 @@
             <a:prstDash val="solid"/>
           </a:ln>
         </p:spPr>
+        <p:txBody>
+          <a:bodyPr/>
+          <a:p/>
+        </p:txBody>
       </p:sp>
       <p:sp>
         <p:nvSpPr>
@@ -11041,7 +12979,7 @@
                 <a:ea typeface="Cambria" pitchFamily="34" charset="-122"/>
                 <a:cs typeface="Cambria" pitchFamily="34" charset="-120"/>
               </a:rPr>
-              <a:t>$237</a:t>
+              <a:t>2 sold out</a:t>
             </a:r>
             <a:endParaRPr lang="en-US" sz="2600" dirty="0"/>
           </a:p>
@@ -11080,7 +13018,7 @@
                 <a:ea typeface="Calibri" pitchFamily="34" charset="-122"/>
                 <a:cs typeface="Calibri" pitchFamily="34" charset="-120"/>
               </a:rPr>
-              <a:t>revenue per Referral customer vs $325 from Email (−29 %)</a:t>
+              <a:t>best sellers out of stock (Noise-Cancelling Headphones ≈ $775 / month); 4 more below reorder level</a:t>
             </a:r>
             <a:endParaRPr lang="en-US" sz="1350" dirty="0"/>
           </a:p>
@@ -11094,7 +13032,7 @@
 </p:sld>
 </file>
 
-<file path=ppt/slides/slide15.xml><?xml version="1.0" encoding="utf-8"?>
+<file path=ppt/slides/slide16.xml><?xml version="1.0" encoding="utf-8"?>
 <p:sld xmlns:a="http://schemas.openxmlformats.org/drawingml/2006/main" xmlns:r="http://schemas.openxmlformats.org/officeDocument/2006/relationships" xmlns:p="http://schemas.openxmlformats.org/presentationml/2006/main">
   <p:cSld name="Slide 15">
     <p:bg>
@@ -11190,7 +13128,7 @@
                 <a:ea typeface="Calibri" pitchFamily="34" charset="-122"/>
                 <a:cs typeface="Calibri" pitchFamily="34" charset="-120"/>
               </a:rPr>
-              <a:t>E-commerce Customer Analytics  ·  15</a:t>
+              <a:t>E-commerce Customer Analytics  ·  16</a:t>
             </a:r>
             <a:endParaRPr lang="en-US" sz="1000" dirty="0"/>
           </a:p>
@@ -11222,6 +13160,10 @@
             <a:prstDash val="solid"/>
           </a:ln>
         </p:spPr>
+        <p:txBody>
+          <a:bodyPr/>
+          <a:p/>
+        </p:txBody>
       </p:sp>
       <p:sp>
         <p:nvSpPr>
@@ -11247,6 +13189,10 @@
             <a:prstDash val="solid"/>
           </a:ln>
         </p:spPr>
+        <p:txBody>
+          <a:bodyPr/>
+          <a:p/>
+        </p:txBody>
       </p:sp>
       <p:sp>
         <p:nvSpPr>
@@ -11359,7 +13305,7 @@
                 <a:ea typeface="Calibri" pitchFamily="34" charset="-122"/>
                 <a:cs typeface="Calibri" pitchFamily="34" charset="-120"/>
               </a:rPr>
-              <a:t>Top 3 markets; show delivery estimates at checkout. Target rating 3.55 → 3.9.</a:t>
+              <a:t>Top 3 markets; show delivery estimates at checkout. Target rating 3.53 → 3.9.</a:t>
             </a:r>
             <a:endParaRPr lang="en-US" sz="1150" dirty="0"/>
           </a:p>
@@ -11430,6 +13376,10 @@
             <a:prstDash val="solid"/>
           </a:ln>
         </p:spPr>
+        <p:txBody>
+          <a:bodyPr/>
+          <a:p/>
+        </p:txBody>
       </p:sp>
       <p:sp>
         <p:nvSpPr>
@@ -11455,6 +13405,10 @@
             <a:prstDash val="solid"/>
           </a:ln>
         </p:spPr>
+        <p:txBody>
+          <a:bodyPr/>
+          <a:p/>
+        </p:txBody>
       </p:sp>
       <p:sp>
         <p:nvSpPr>
@@ -11567,7 +13521,7 @@
                 <a:ea typeface="Calibri" pitchFamily="34" charset="-122"/>
                 <a:cs typeface="Calibri" pitchFamily="34" charset="-120"/>
               </a:rPr>
-              <a:t>Voucher 14 days after first delivery; win-back for the 45 % dormant. New repeat 40 % → 70 %.</a:t>
+              <a:t>Voucher 14 days after first delivery; win-back for the 45 % dormant. New repeat 40 % → 71 %.</a:t>
             </a:r>
             <a:endParaRPr lang="en-US" sz="1150" dirty="0"/>
           </a:p>
@@ -11638,6 +13592,10 @@
             <a:prstDash val="solid"/>
           </a:ln>
         </p:spPr>
+        <p:txBody>
+          <a:bodyPr/>
+          <a:p/>
+        </p:txBody>
       </p:sp>
       <p:sp>
         <p:nvSpPr>
@@ -11663,6 +13621,10 @@
             <a:prstDash val="solid"/>
           </a:ln>
         </p:spPr>
+        <p:txBody>
+          <a:bodyPr/>
+          <a:p/>
+        </p:txBody>
       </p:sp>
       <p:sp>
         <p:nvSpPr>
@@ -11736,7 +13698,7 @@
                 <a:ea typeface="Cambria" pitchFamily="34" charset="-122"/>
                 <a:cs typeface="Cambria" pitchFamily="34" charset="-120"/>
               </a:rPr>
-              <a:t>Cut Fashion &amp; Sports returns</a:t>
+              <a:t>Cut Fashion returns</a:t>
             </a:r>
             <a:endParaRPr lang="en-US" sz="1500" dirty="0"/>
           </a:p>
@@ -11775,7 +13737,7 @@
                 <a:ea typeface="Calibri" pitchFamily="34" charset="-122"/>
                 <a:cs typeface="Calibri" pitchFamily="34" charset="-120"/>
               </a:rPr>
-              <a:t>Size guides, fit reviews, more photos, return-reason tracking. Fashion 13.6 % → 10 %.</a:t>
+              <a:t>Size guides, fit reviews, more photos; start with Slim-Fit Jeans (24 %). Fashion 15.7 % → 11 %.</a:t>
             </a:r>
             <a:endParaRPr lang="en-US" sz="1150" dirty="0"/>
           </a:p>
@@ -11846,6 +13808,10 @@
             <a:prstDash val="solid"/>
           </a:ln>
         </p:spPr>
+        <p:txBody>
+          <a:bodyPr/>
+          <a:p/>
+        </p:txBody>
       </p:sp>
       <p:sp>
         <p:nvSpPr>
@@ -11871,6 +13837,10 @@
             <a:prstDash val="solid"/>
           </a:ln>
         </p:spPr>
+        <p:txBody>
+          <a:bodyPr/>
+          <a:p/>
+        </p:txBody>
       </p:sp>
       <p:sp>
         <p:nvSpPr>
@@ -11983,7 +13953,7 @@
                 <a:ea typeface="Calibri" pitchFamily="34" charset="-122"/>
                 <a:cs typeface="Calibri" pitchFamily="34" charset="-120"/>
               </a:rPr>
-              <a:t>Cross-sell Home &amp; Kitchen / Sports bundles; push Beauty in high-AOV markets.</a:t>
+              <a:t>Cross-sell Home &amp; Kitchen appliances (Air Fryer, Rice Cooker) and Sports bundles to Electronics buyers.</a:t>
             </a:r>
             <a:endParaRPr lang="en-US" sz="1150" dirty="0"/>
           </a:p>
@@ -12054,6 +14024,10 @@
             <a:prstDash val="solid"/>
           </a:ln>
         </p:spPr>
+        <p:txBody>
+          <a:bodyPr/>
+          <a:p/>
+        </p:txBody>
       </p:sp>
       <p:sp>
         <p:nvSpPr>
@@ -12079,6 +14053,10 @@
             <a:prstDash val="solid"/>
           </a:ln>
         </p:spPr>
+        <p:txBody>
+          <a:bodyPr/>
+          <a:p/>
+        </p:txBody>
       </p:sp>
       <p:sp>
         <p:nvSpPr>
@@ -12191,7 +14169,7 @@
                 <a:ea typeface="Calibri" pitchFamily="34" charset="-122"/>
                 <a:cs typeface="Calibri" pitchFamily="34" charset="-120"/>
               </a:rPr>
-              <a:t>Stock &amp; ad budget for Nov–Dec; January promotion to soften the trough (−63 % → −40 %).</a:t>
+              <a:t>Stock &amp; ad budget for Nov–Dec; January promotion to soften the trough (−45 % → −30 %).</a:t>
             </a:r>
             <a:endParaRPr lang="en-US" sz="1150" dirty="0"/>
           </a:p>
@@ -12262,6 +14240,10 @@
             <a:prstDash val="solid"/>
           </a:ln>
         </p:spPr>
+        <p:txBody>
+          <a:bodyPr/>
+          <a:p/>
+        </p:txBody>
       </p:sp>
       <p:sp>
         <p:nvSpPr>
@@ -12287,6 +14269,10 @@
             <a:prstDash val="solid"/>
           </a:ln>
         </p:spPr>
+        <p:txBody>
+          <a:bodyPr/>
+          <a:p/>
+        </p:txBody>
       </p:sp>
       <p:sp>
         <p:nvSpPr>
@@ -12399,7 +14385,7 @@
                 <a:ea typeface="Calibri" pitchFamily="34" charset="-122"/>
                 <a:cs typeface="Calibri" pitchFamily="34" charset="-120"/>
               </a:rPr>
-              <a:t>Shift Referral budget to Email / Social; pay referral rewards after the 2nd order.</a:t>
+              <a:t>Shift Referral budget to Email / Organic Search; pay referral rewards after the 2nd order.</a:t>
             </a:r>
             <a:endParaRPr lang="en-US" sz="1150" dirty="0"/>
           </a:p>
@@ -12470,6 +14456,10 @@
             <a:prstDash val="solid"/>
           </a:ln>
         </p:spPr>
+        <p:txBody>
+          <a:bodyPr/>
+          <a:p/>
+        </p:txBody>
       </p:sp>
       <p:sp>
         <p:nvSpPr>
@@ -12495,6 +14485,10 @@
             <a:prstDash val="solid"/>
           </a:ln>
         </p:spPr>
+        <p:txBody>
+          <a:bodyPr/>
+          <a:p/>
+        </p:txBody>
       </p:sp>
       <p:sp>
         <p:nvSpPr>
@@ -12568,7 +14562,7 @@
                 <a:ea typeface="Cambria" pitchFamily="34" charset="-122"/>
                 <a:cs typeface="Cambria" pitchFamily="34" charset="-120"/>
               </a:rPr>
-              <a:t>Protect VIP margin</a:t>
+              <a:t>Reorder from stock cover</a:t>
             </a:r>
             <a:endParaRPr lang="en-US" sz="1500" dirty="0"/>
           </a:p>
@@ -12607,7 +14601,7 @@
                 <a:ea typeface="Calibri" pitchFamily="34" charset="-122"/>
                 <a:cs typeface="Calibri" pitchFamily="34" charset="-120"/>
               </a:rPr>
-              <a:t>Cap discounts at ~10 %; replace with free express shipping (supports R1).</a:t>
+              <a:t>Restock the 2 sold-out products now; reorder below 2 months of cover (flagged in the web app).</a:t>
             </a:r>
             <a:endParaRPr lang="en-US" sz="1150" dirty="0"/>
           </a:p>
@@ -12646,7 +14640,7 @@
                 <a:ea typeface="Calibri" pitchFamily="34" charset="-122"/>
                 <a:cs typeface="Calibri" pitchFamily="34" charset="-120"/>
               </a:rPr>
-              <a:t>F2</a:t>
+              <a:t>F8</a:t>
             </a:r>
             <a:endParaRPr lang="en-US" sz="1000" dirty="0"/>
           </a:p>
@@ -12678,6 +14672,10 @@
             <a:prstDash val="solid"/>
           </a:ln>
         </p:spPr>
+        <p:txBody>
+          <a:bodyPr/>
+          <a:p/>
+        </p:txBody>
       </p:sp>
       <p:sp>
         <p:nvSpPr>
@@ -12726,7 +14724,7 @@
 </p:sld>
 </file>
 
-<file path=ppt/slides/slide16.xml><?xml version="1.0" encoding="utf-8"?>
+<file path=ppt/slides/slide17.xml><?xml version="1.0" encoding="utf-8"?>
 <p:sld xmlns:a="http://schemas.openxmlformats.org/drawingml/2006/main" xmlns:r="http://schemas.openxmlformats.org/officeDocument/2006/relationships" xmlns:p="http://schemas.openxmlformats.org/presentationml/2006/main">
   <p:cSld name="Slide 16">
     <p:bg>
@@ -12822,7 +14820,7 @@
                 <a:ea typeface="Calibri" pitchFamily="34" charset="-122"/>
                 <a:cs typeface="Calibri" pitchFamily="34" charset="-120"/>
               </a:rPr>
-              <a:t>E-commerce Customer Analytics  ·  16</a:t>
+              <a:t>E-commerce Customer Analytics  ·  17</a:t>
             </a:r>
             <a:endParaRPr lang="en-US" sz="1000" dirty="0"/>
           </a:p>
@@ -12854,6 +14852,10 @@
             <a:prstDash val="solid"/>
           </a:ln>
         </p:spPr>
+        <p:txBody>
+          <a:bodyPr/>
+          <a:p/>
+        </p:txBody>
       </p:sp>
       <p:sp>
         <p:nvSpPr>
@@ -12930,7 +14932,7 @@
                 <a:ea typeface="Courier New" pitchFamily="34" charset="-122"/>
                 <a:cs typeface="Courier New" pitchFamily="34" charset="-120"/>
               </a:rPr>
-              <a:t>├── data/raw/ecommerce_orders_raw.csv</a:t>
+              <a:t>├── data/  raw + processed (orders, products)</a:t>
             </a:r>
             <a:endParaRPr lang="en-US" sz="1200" dirty="0"/>
           </a:p>
@@ -12950,7 +14952,7 @@
                 <a:ea typeface="Courier New" pitchFamily="34" charset="-122"/>
                 <a:cs typeface="Courier New" pitchFamily="34" charset="-120"/>
               </a:rPr>
-              <a:t>├── data/processed/ecommerce_orders_clean.csv</a:t>
+              <a:t>├── notebooks/  analysis notebook</a:t>
             </a:r>
             <a:endParaRPr lang="en-US" sz="1200" dirty="0"/>
           </a:p>
@@ -12970,7 +14972,7 @@
                 <a:ea typeface="Courier New" pitchFamily="34" charset="-122"/>
                 <a:cs typeface="Courier New" pitchFamily="34" charset="-120"/>
               </a:rPr>
-              <a:t>├── notebooks/ecommerce_customer_analytics.ipynb</a:t>
+              <a:t>├── src/  generator · cleaning · pipeline</a:t>
             </a:r>
             <a:endParaRPr lang="en-US" sz="1200" dirty="0"/>
           </a:p>
@@ -12990,7 +14992,7 @@
                 <a:ea typeface="Courier New" pitchFamily="34" charset="-122"/>
                 <a:cs typeface="Courier New" pitchFamily="34" charset="-120"/>
               </a:rPr>
-              <a:t>├── src/generate_dataset.py</a:t>
+              <a:t>├── webapp/  Flask + SQLite app</a:t>
             </a:r>
             <a:endParaRPr lang="en-US" sz="1200" dirty="0"/>
           </a:p>
@@ -13010,7 +15012,7 @@
                 <a:ea typeface="Courier New" pitchFamily="34" charset="-122"/>
                 <a:cs typeface="Courier New" pitchFamily="34" charset="-120"/>
               </a:rPr>
-              <a:t>├── src/data_cleaning.py</a:t>
+              <a:t>├── tests/  pytest suite</a:t>
             </a:r>
             <a:endParaRPr lang="en-US" sz="1200" dirty="0"/>
           </a:p>
@@ -13030,7 +15032,7 @@
                 <a:ea typeface="Courier New" pitchFamily="34" charset="-122"/>
                 <a:cs typeface="Courier New" pitchFamily="34" charset="-120"/>
               </a:rPr>
-              <a:t>├── outputs/figures/  (9 charts)</a:t>
+              <a:t>├── outputs/figures/  10 charts</a:t>
             </a:r>
             <a:endParaRPr lang="en-US" sz="1200" dirty="0"/>
           </a:p>
@@ -13050,7 +15052,7 @@
                 <a:ea typeface="Courier New" pitchFamily="34" charset="-122"/>
                 <a:cs typeface="Courier New" pitchFamily="34" charset="-120"/>
               </a:rPr>
-              <a:t>├── docs/data_dictionary.md · project_report.docx</a:t>
+              <a:t>├── docs/  report · slides · dashboard</a:t>
             </a:r>
             <a:endParaRPr lang="en-US" sz="1200" dirty="0"/>
           </a:p>
@@ -13070,7 +15072,7 @@
                 <a:ea typeface="Courier New" pitchFamily="34" charset="-122"/>
                 <a:cs typeface="Courier New" pitchFamily="34" charset="-120"/>
               </a:rPr>
-              <a:t>├── README.md</a:t>
+              <a:t>├── README.md · requirements.txt</a:t>
             </a:r>
             <a:endParaRPr lang="en-US" sz="1200" dirty="0"/>
           </a:p>
@@ -13090,27 +15092,7 @@
                 <a:ea typeface="Courier New" pitchFamily="34" charset="-122"/>
                 <a:cs typeface="Courier New" pitchFamily="34" charset="-120"/>
               </a:rPr>
-              <a:t>├── requirements.txt</a:t>
-            </a:r>
-            <a:endParaRPr lang="en-US" sz="1200" dirty="0"/>
-          </a:p>
-          <a:p>
-            <a:pPr indent="0" marL="0">
-              <a:lnSpc>
-                <a:spcPct val="125000"/>
-              </a:lnSpc>
-              <a:buNone/>
-            </a:pPr>
-            <a:r>
-              <a:rPr lang="en-US" sz="1200" dirty="0">
-                <a:solidFill>
-                  <a:srgbClr val="FFFFFF"/>
-                </a:solidFill>
-                <a:latin typeface="Courier New" pitchFamily="34" charset="0"/>
-                <a:ea typeface="Courier New" pitchFamily="34" charset="-122"/>
-                <a:cs typeface="Courier New" pitchFamily="34" charset="-120"/>
-              </a:rPr>
-              <a:t>└── .gitignore</a:t>
+              <a:t>└── .github/workflows/ci.yml</a:t>
             </a:r>
             <a:endParaRPr lang="en-US" sz="1200" dirty="0"/>
           </a:p>
@@ -13149,7 +15131,7 @@
                 <a:ea typeface="Calibri" pitchFamily="34" charset="-122"/>
                 <a:cs typeface="Calibri" pitchFamily="34" charset="-120"/>
               </a:rPr>
-              <a:t>Commit history: scaffold → generator → cleaning pipeline → notebook → docs. Run: pip install -r requirements.txt → Restart &amp; Run All (~15 s).</a:t>
+              <a:t>Commit history: scaffold → generator → cleaning pipeline → notebook → docs → web app → product catalogue. Run: pip install -r requirements.txt → python src/run_pipeline.py → python webapp/app.py.</a:t>
             </a:r>
             <a:endParaRPr lang="en-US" sz="1200" dirty="0"/>
           </a:p>
@@ -13218,6 +15200,10 @@
             <a:prstDash val="solid"/>
           </a:ln>
         </p:spPr>
+        <p:txBody>
+          <a:bodyPr/>
+          <a:p/>
+        </p:txBody>
       </p:sp>
       <p:sp>
         <p:nvSpPr>
@@ -13360,6 +15346,10 @@
             <a:prstDash val="solid"/>
           </a:ln>
         </p:spPr>
+        <p:txBody>
+          <a:bodyPr/>
+          <a:p/>
+        </p:txBody>
       </p:sp>
       <p:sp>
         <p:nvSpPr>
@@ -13502,6 +15492,10 @@
             <a:prstDash val="solid"/>
           </a:ln>
         </p:spPr>
+        <p:txBody>
+          <a:bodyPr/>
+          <a:p/>
+        </p:txBody>
       </p:sp>
       <p:sp>
         <p:nvSpPr>
@@ -13644,6 +15638,10 @@
             <a:prstDash val="solid"/>
           </a:ln>
         </p:spPr>
+        <p:txBody>
+          <a:bodyPr/>
+          <a:p/>
+        </p:txBody>
       </p:sp>
       <p:sp>
         <p:nvSpPr>
@@ -13786,6 +15784,10 @@
             <a:prstDash val="solid"/>
           </a:ln>
         </p:spPr>
+        <p:txBody>
+          <a:bodyPr/>
+          <a:p/>
+        </p:txBody>
       </p:sp>
       <p:sp>
         <p:nvSpPr>
@@ -14079,6 +16081,10 @@
             <a:prstDash val="solid"/>
           </a:ln>
         </p:spPr>
+        <p:txBody>
+          <a:bodyPr/>
+          <a:p/>
+        </p:txBody>
       </p:sp>
       <p:sp>
         <p:nvSpPr>
@@ -14305,6 +16311,10 @@
             <a:prstDash val="solid"/>
           </a:ln>
         </p:spPr>
+        <p:txBody>
+          <a:bodyPr/>
+          <a:p/>
+        </p:txBody>
       </p:sp>
       <p:sp>
         <p:nvSpPr>
@@ -14382,7 +16392,7 @@
                 <a:ea typeface="Calibri" pitchFamily="34" charset="-122"/>
                 <a:cs typeface="Calibri" pitchFamily="34" charset="-120"/>
               </a:rPr>
-              <a:t>Order-level data, 1 Jan 2024 – 30 Jun 2025 (2,045 raw → 1,972 clean rows)</a:t>
+              <a:t>Order-level data, 1 Jan 2024 – 30 Jun 2025 (2,045 raw → 1,995 clean rows)</a:t>
             </a:r>
             <a:endParaRPr lang="en-US" sz="1250" dirty="0"/>
           </a:p>
@@ -14403,7 +16413,7 @@
                 <a:ea typeface="Calibri" pitchFamily="34" charset="-122"/>
                 <a:cs typeface="Calibri" pitchFamily="34" charset="-120"/>
               </a:rPr>
-              <a:t>Customer attributes: age, gender, country, segment, channel</a:t>
+              <a:t>60-product catalogue: 7 categories, 30 subcategories, fixed prices, stock on hand</a:t>
             </a:r>
             <a:endParaRPr lang="en-US" sz="1250" dirty="0"/>
           </a:p>
@@ -14424,7 +16434,25 @@
                 <a:ea typeface="Calibri" pitchFamily="34" charset="-122"/>
                 <a:cs typeface="Calibri" pitchFamily="34" charset="-120"/>
               </a:rPr>
-              <a:t>Order attributes: category, price, discount, payment, device, delivery, status, rating</a:t>
+              <a:t>Customer attributes: age, gender, country, segment, channel</a:t>
+            </a:r>
+            <a:endParaRPr lang="en-US" sz="1250" dirty="0"/>
+          </a:p>
+          <a:p>
+            <a:pPr marL="342900" indent="-342900">
+              <a:buSzPct val="100000"/>
+              <a:buChar char="•"/>
+            </a:pPr>
+            <a:r>
+              <a:rPr lang="en-US" sz="1250" dirty="0">
+                <a:solidFill>
+                  <a:srgbClr val="1F2937"/>
+                </a:solidFill>
+                <a:latin typeface="Calibri" pitchFamily="34" charset="0"/>
+                <a:ea typeface="Calibri" pitchFamily="34" charset="-122"/>
+                <a:cs typeface="Calibri" pitchFamily="34" charset="-120"/>
+              </a:rPr>
+              <a:t>Order attributes: product, price, discount, payment, device, delivery, status, rating</a:t>
             </a:r>
             <a:endParaRPr lang="en-US" sz="1250" dirty="0"/>
           </a:p>
@@ -14474,6 +16502,10 @@
             <a:prstDash val="solid"/>
           </a:ln>
         </p:spPr>
+        <p:txBody>
+          <a:bodyPr/>
+          <a:p/>
+        </p:txBody>
       </p:sp>
       <p:sp>
         <p:nvSpPr>
@@ -14551,7 +16583,7 @@
                 <a:ea typeface="Calibri" pitchFamily="34" charset="-122"/>
                 <a:cs typeface="Calibri" pitchFamily="34" charset="-120"/>
               </a:rPr>
-              <a:t>SKU-level product analysis (data is at category level)</a:t>
+              <a:t>Cost of goods, profit margin, marketing spend</a:t>
             </a:r>
             <a:endParaRPr lang="en-US" sz="1250" dirty="0"/>
           </a:p>
@@ -14572,7 +16604,7 @@
                 <a:ea typeface="Calibri" pitchFamily="34" charset="-122"/>
                 <a:cs typeface="Calibri" pitchFamily="34" charset="-120"/>
               </a:rPr>
-              <a:t>Cost of goods, profit margin, marketing spend</a:t>
+              <a:t>Price changes and promotions over time</a:t>
             </a:r>
             <a:endParaRPr lang="en-US" sz="1250" dirty="0"/>
           </a:p>
@@ -14753,6 +16785,10 @@
             <a:prstDash val="solid"/>
           </a:ln>
         </p:spPr>
+        <p:txBody>
+          <a:bodyPr/>
+          <a:p/>
+        </p:txBody>
       </p:sp>
       <p:sp>
         <p:nvSpPr>
@@ -14778,6 +16814,10 @@
             <a:prstDash val="solid"/>
           </a:ln>
         </p:spPr>
+        <p:txBody>
+          <a:bodyPr/>
+          <a:p/>
+        </p:txBody>
       </p:sp>
       <p:sp>
         <p:nvSpPr>
@@ -14890,7 +16930,7 @@
                 <a:ea typeface="Calibri" pitchFamily="34" charset="-122"/>
                 <a:cs typeface="Calibri" pitchFamily="34" charset="-120"/>
               </a:rPr>
-              <a:t>Quantify revenue share by category, segment, country and channel; find the groups producing ≥ 80 % of revenue.</a:t>
+              <a:t>Quantify revenue share by category, subcategory, product, segment, country and channel; find the groups producing ≥ 80 % of revenue.</a:t>
             </a:r>
             <a:endParaRPr lang="en-US" sz="1350" dirty="0"/>
           </a:p>
@@ -15000,6 +17040,10 @@
             <a:prstDash val="solid"/>
           </a:ln>
         </p:spPr>
+        <p:txBody>
+          <a:bodyPr/>
+          <a:p/>
+        </p:txBody>
       </p:sp>
       <p:sp>
         <p:nvSpPr>
@@ -15025,6 +17069,10 @@
             <a:prstDash val="solid"/>
           </a:ln>
         </p:spPr>
+        <p:txBody>
+          <a:bodyPr/>
+          <a:p/>
+        </p:txBody>
       </p:sp>
       <p:sp>
         <p:nvSpPr>
@@ -15247,6 +17295,10 @@
             <a:prstDash val="solid"/>
           </a:ln>
         </p:spPr>
+        <p:txBody>
+          <a:bodyPr/>
+          <a:p/>
+        </p:txBody>
       </p:sp>
       <p:sp>
         <p:nvSpPr>
@@ -15272,6 +17324,10 @@
             <a:prstDash val="solid"/>
           </a:ln>
         </p:spPr>
+        <p:txBody>
+          <a:bodyPr/>
+          <a:p/>
+        </p:txBody>
       </p:sp>
       <p:sp>
         <p:nvSpPr>
@@ -15533,7 +17589,7 @@
                 <a:ea typeface="Cambria" pitchFamily="34" charset="-122"/>
                 <a:cs typeface="Cambria" pitchFamily="34" charset="-120"/>
               </a:rPr>
-              <a:t>2 · Seven analytical questions</a:t>
+              <a:t>2 · Analytical questions (Q1–Q8)</a:t>
             </a:r>
             <a:endParaRPr lang="en-US" sz="3200" dirty="0"/>
           </a:p>
@@ -15604,6 +17660,10 @@
             <a:prstDash val="solid"/>
           </a:ln>
         </p:spPr>
+        <p:txBody>
+          <a:bodyPr/>
+          <a:p/>
+        </p:txBody>
       </p:sp>
       <p:sp>
         <p:nvSpPr>
@@ -15629,6 +17689,10 @@
             <a:prstDash val="solid"/>
           </a:ln>
         </p:spPr>
+        <p:txBody>
+          <a:bodyPr/>
+          <a:p/>
+        </p:txBody>
       </p:sp>
       <p:sp>
         <p:nvSpPr>
@@ -15773,6 +17837,10 @@
             <a:prstDash val="solid"/>
           </a:ln>
         </p:spPr>
+        <p:txBody>
+          <a:bodyPr/>
+          <a:p/>
+        </p:txBody>
       </p:sp>
       <p:sp>
         <p:nvSpPr>
@@ -15798,6 +17866,10 @@
             <a:prstDash val="solid"/>
           </a:ln>
         </p:spPr>
+        <p:txBody>
+          <a:bodyPr/>
+          <a:p/>
+        </p:txBody>
       </p:sp>
       <p:sp>
         <p:nvSpPr>
@@ -15942,6 +18014,10 @@
             <a:prstDash val="solid"/>
           </a:ln>
         </p:spPr>
+        <p:txBody>
+          <a:bodyPr/>
+          <a:p/>
+        </p:txBody>
       </p:sp>
       <p:sp>
         <p:nvSpPr>
@@ -15967,6 +18043,10 @@
             <a:prstDash val="solid"/>
           </a:ln>
         </p:spPr>
+        <p:txBody>
+          <a:bodyPr/>
+          <a:p/>
+        </p:txBody>
       </p:sp>
       <p:sp>
         <p:nvSpPr>
@@ -16111,6 +18191,10 @@
             <a:prstDash val="solid"/>
           </a:ln>
         </p:spPr>
+        <p:txBody>
+          <a:bodyPr/>
+          <a:p/>
+        </p:txBody>
       </p:sp>
       <p:sp>
         <p:nvSpPr>
@@ -16136,6 +18220,10 @@
             <a:prstDash val="solid"/>
           </a:ln>
         </p:spPr>
+        <p:txBody>
+          <a:bodyPr/>
+          <a:p/>
+        </p:txBody>
       </p:sp>
       <p:sp>
         <p:nvSpPr>
@@ -16280,6 +18368,10 @@
             <a:prstDash val="solid"/>
           </a:ln>
         </p:spPr>
+        <p:txBody>
+          <a:bodyPr/>
+          <a:p/>
+        </p:txBody>
       </p:sp>
       <p:sp>
         <p:nvSpPr>
@@ -16305,6 +18397,10 @@
             <a:prstDash val="solid"/>
           </a:ln>
         </p:spPr>
+        <p:txBody>
+          <a:bodyPr/>
+          <a:p/>
+        </p:txBody>
       </p:sp>
       <p:sp>
         <p:nvSpPr>
@@ -16449,6 +18545,10 @@
             <a:prstDash val="solid"/>
           </a:ln>
         </p:spPr>
+        <p:txBody>
+          <a:bodyPr/>
+          <a:p/>
+        </p:txBody>
       </p:sp>
       <p:sp>
         <p:nvSpPr>
@@ -16474,6 +18574,10 @@
             <a:prstDash val="solid"/>
           </a:ln>
         </p:spPr>
+        <p:txBody>
+          <a:bodyPr/>
+          <a:p/>
+        </p:txBody>
       </p:sp>
       <p:sp>
         <p:nvSpPr>
@@ -16618,6 +18722,10 @@
             <a:prstDash val="solid"/>
           </a:ln>
         </p:spPr>
+        <p:txBody>
+          <a:bodyPr/>
+          <a:p/>
+        </p:txBody>
       </p:sp>
       <p:sp>
         <p:nvSpPr>
@@ -16643,6 +18751,10 @@
             <a:prstDash val="solid"/>
           </a:ln>
         </p:spPr>
+        <p:txBody>
+          <a:bodyPr/>
+          <a:p/>
+        </p:txBody>
       </p:sp>
       <p:sp>
         <p:nvSpPr>
@@ -16787,6 +18899,10 @@
             <a:prstDash val="solid"/>
           </a:ln>
         </p:spPr>
+        <p:txBody>
+          <a:bodyPr/>
+          <a:p/>
+        </p:txBody>
       </p:sp>
       <p:sp>
         <p:nvSpPr>
@@ -16821,7 +18937,7 @@
                 <a:ea typeface="Calibri" pitchFamily="34" charset="-122"/>
                 <a:cs typeface="Calibri" pitchFamily="34" charset="-120"/>
               </a:rPr>
-              <a:t>Each question is answered in the notebook with a table, a chart and a written interpretation, and links back to an objective (O1–O3).</a:t>
+              <a:t>Plus Q8 — which products and subcategories sell best, and which are about to run out of stock? Each question is answered in the notebook with a table, a chart and a written interpretation, and links back to an objective (O1–O3).</a:t>
             </a:r>
             <a:endParaRPr lang="en-US" sz="1250" dirty="0"/>
           </a:p>
@@ -17048,7 +19164,7 @@
                 <a:ea typeface="Cambria" pitchFamily="34" charset="-122"/>
                 <a:cs typeface="Cambria" pitchFamily="34" charset="-120"/>
               </a:rPr>
-              <a:t>20</a:t>
+              <a:t>22</a:t>
             </a:r>
             <a:endParaRPr lang="en-US" sz="4000" dirty="0"/>
           </a:p>
@@ -17087,7 +19203,7 @@
                 <a:ea typeface="Calibri" pitchFamily="34" charset="-122"/>
                 <a:cs typeface="Calibri" pitchFamily="34" charset="-120"/>
               </a:rPr>
-              <a:t>columns (+11 derived)</a:t>
+              <a:t>columns + 60-product catalogue</a:t>
             </a:r>
             <a:endParaRPr lang="en-US" sz="1200" dirty="0"/>
           </a:p>
@@ -17126,7 +19242,7 @@
                 <a:ea typeface="Cambria" pitchFamily="34" charset="-122"/>
                 <a:cs typeface="Cambria" pitchFamily="34" charset="-120"/>
               </a:rPr>
-              <a:t>721</a:t>
+              <a:t>723</a:t>
             </a:r>
             <a:endParaRPr lang="en-US" sz="4000" dirty="0"/>
           </a:p>
@@ -17282,7 +19398,7 @@
                 <a:ea typeface="Calibri" pitchFamily="34" charset="-122"/>
                 <a:cs typeface="Calibri" pitchFamily="34" charset="-120"/>
               </a:rPr>
-              <a:t>Synthetic but realistic — generated by src/generate_dataset.py (seed 42) with seasonal demand, segment-dependent frequency, category-specific prices and return rates, and a delivery-time → rating link. Realistic defects are injected on purpose: missing values, 45 duplicates, 25 out-of-range values, inconsistent category spelling.</a:t>
+              <a:t>Synthetic but realistic — generated by src/generate_dataset.py (seed 42): first a product catalogue (e.g. Books → Comics &amp; Manga, Programming, Fiction) with one fixed price and a stock level per product, then 2,000 orders with seasonal demand, segment-dependent frequency, product popularity, category return rates and a delivery-time → rating link. Defects are injected on purpose: missing values, 45 duplicates, 25 out-of-range values, wrong prices and inconsistent spelling.</a:t>
             </a:r>
             <a:endParaRPr lang="en-US" sz="1300" dirty="0"/>
           </a:p>
@@ -18704,7 +20820,7 @@
                           <a:ea typeface="Calibri" pitchFamily="34" charset="-122"/>
                           <a:cs typeface="Calibri" pitchFamily="34" charset="-120"/>
                         </a:rPr>
-                        <a:t>product_category</a:t>
+                        <a:t>product_id, product_name, category</a:t>
                       </a:r>
                       <a:endParaRPr lang="en-US" sz="1100" dirty="0">
                         <a:latin typeface="Calibri" charset="0"/>
@@ -18772,7 +20888,7 @@
                           <a:ea typeface="Calibri" pitchFamily="34" charset="-122"/>
                           <a:cs typeface="Calibri" pitchFamily="34" charset="-120"/>
                         </a:rPr>
-                        <a:t>category</a:t>
+                        <a:t>string / category</a:t>
                       </a:r>
                       <a:endParaRPr lang="en-US" sz="1100" dirty="0">
                         <a:latin typeface="Calibri" charset="0"/>
@@ -18840,7 +20956,7 @@
                           <a:ea typeface="Calibri" pitchFamily="34" charset="-122"/>
                           <a:cs typeface="Calibri" pitchFamily="34" charset="-120"/>
                         </a:rPr>
-                        <a:t>Electronics, Fashion, Home &amp; Kitchen, Beauty, Sports, Books, Toys</a:t>
+                        <a:t>Product from the catalogue (60 products, 30 subcategories)</a:t>
                       </a:r>
                       <a:endParaRPr lang="en-US" sz="1100" dirty="0">
                         <a:latin typeface="Calibri" charset="0"/>
@@ -18908,7 +21024,7 @@
                           <a:ea typeface="Calibri" pitchFamily="34" charset="-122"/>
                           <a:cs typeface="Calibri" pitchFamily="34" charset="-120"/>
                         </a:rPr>
-                        <a:t>Beauty</a:t>
+                        <a:t>P036, Herbal Shampoo, Beauty</a:t>
                       </a:r>
                       <a:endParaRPr lang="en-US" sz="1100" dirty="0">
                         <a:latin typeface="Calibri" charset="0"/>
@@ -19114,7 +21230,7 @@
                           <a:ea typeface="Calibri" pitchFamily="34" charset="-122"/>
                           <a:cs typeface="Calibri" pitchFamily="34" charset="-120"/>
                         </a:rPr>
-                        <a:t>Basket economics (USD, %)</a:t>
+                        <a:t>Basket economics — unit_price = the product's fixed list price</a:t>
                       </a:r>
                       <a:endParaRPr lang="en-US" sz="1100" dirty="0">
                         <a:latin typeface="Calibri" charset="0"/>
@@ -19182,7 +21298,7 @@
                           <a:ea typeface="Calibri" pitchFamily="34" charset="-122"/>
                           <a:cs typeface="Calibri" pitchFamily="34" charset="-120"/>
                         </a:rPr>
-                        <a:t>1, 37.40, 5.0, 9.99</a:t>
+                        <a:t>2, 9.00, 0.0, 6.99</a:t>
                       </a:r>
                       <a:endParaRPr lang="en-US" sz="1100" dirty="0">
                         <a:latin typeface="Calibri" charset="0"/>
@@ -19819,7 +21935,7 @@
                 <a:ea typeface="Calibri" pitchFamily="34" charset="-122"/>
                 <a:cs typeface="Calibri" pitchFamily="34" charset="-120"/>
               </a:rPr>
-              <a:t>Full 31-column dictionary in docs/data_dictionary.md</a:t>
+              <a:t>Full 34-column dictionary and the catalogue fields in docs/data_dictionary.md</a:t>
             </a:r>
             <a:endParaRPr lang="en-US" sz="1100" dirty="0"/>
           </a:p>
@@ -19961,6 +22077,10 @@
             <a:prstDash val="solid"/>
           </a:ln>
         </p:spPr>
+        <p:txBody>
+          <a:bodyPr/>
+          <a:p/>
+        </p:txBody>
       </p:sp>
       <p:sp>
         <p:nvSpPr>
@@ -19986,6 +22106,10 @@
             <a:prstDash val="solid"/>
           </a:ln>
         </p:spPr>
+        <p:txBody>
+          <a:bodyPr/>
+          <a:p/>
+        </p:txBody>
       </p:sp>
       <p:sp>
         <p:nvSpPr>
@@ -20137,7 +22261,7 @@
                 <a:ea typeface="Calibri" pitchFamily="34" charset="-122"/>
                 <a:cs typeface="Calibri" pitchFamily="34" charset="-120"/>
               </a:rPr>
-              <a:t>describe() exposes age −5…210, quantity −2, discount 150 %, rating 0–7</a:t>
+              <a:t>describe() exposes age −5…210, quantity −2, discount 150 %, rating 0–7, negative prices</a:t>
             </a:r>
             <a:endParaRPr lang="en-US" sz="1200" dirty="0"/>
           </a:p>
@@ -20208,6 +22332,10 @@
             <a:prstDash val="solid"/>
           </a:ln>
         </p:spPr>
+        <p:txBody>
+          <a:bodyPr/>
+          <a:p/>
+        </p:txBody>
       </p:sp>
       <p:sp>
         <p:nvSpPr>
@@ -20233,6 +22361,10 @@
             <a:prstDash val="solid"/>
           </a:ln>
         </p:spPr>
+        <p:txBody>
+          <a:bodyPr/>
+          <a:p/>
+        </p:txBody>
       </p:sp>
       <p:sp>
         <p:nvSpPr>
@@ -20345,7 +22477,7 @@
                 <a:ea typeface="Calibri" pitchFamily="34" charset="-122"/>
                 <a:cs typeface="Calibri" pitchFamily="34" charset="-120"/>
               </a:rPr>
-              <a:t>strip / title-case categories, F→Female</a:t>
+              <a:t>strip / title-case categories &amp; product names, F→Female</a:t>
             </a:r>
             <a:endParaRPr lang="en-US" sz="1150" dirty="0"/>
           </a:p>
@@ -20455,6 +22587,10 @@
             <a:prstDash val="solid"/>
           </a:ln>
         </p:spPr>
+        <p:txBody>
+          <a:bodyPr/>
+          <a:p/>
+        </p:txBody>
       </p:sp>
       <p:sp>
         <p:nvSpPr>
@@ -20480,6 +22616,10 @@
             <a:prstDash val="solid"/>
           </a:ln>
         </p:spPr>
+        <p:txBody>
+          <a:bodyPr/>
+          <a:p/>
+        </p:txBody>
       </p:sp>
       <p:sp>
         <p:nvSpPr>
@@ -20702,6 +22842,10 @@
             <a:prstDash val="solid"/>
           </a:ln>
         </p:spPr>
+        <p:txBody>
+          <a:bodyPr/>
+          <a:p/>
+        </p:txBody>
       </p:sp>
       <p:sp>
         <p:nvSpPr>
@@ -20727,6 +22871,10 @@
             <a:prstDash val="solid"/>
           </a:ln>
         </p:spPr>
+        <p:txBody>
+          <a:bodyPr/>
+          <a:p/>
+        </p:txBody>
       </p:sp>
       <p:sp>
         <p:nvSpPr>
@@ -20878,7 +23026,7 @@
                 <a:ea typeface="Calibri" pitchFamily="34" charset="-122"/>
                 <a:cs typeface="Calibri" pitchFamily="34" charset="-120"/>
               </a:rPr>
-              <a:t>25 impossible values → NaN; 28 unusable rows dropped</a:t>
+              <a:t>25 impossible → NaN; 5 rows dropped; 23 prices restored from the catalogue</a:t>
             </a:r>
             <a:endParaRPr lang="en-US" sz="1200" dirty="0"/>
           </a:p>
@@ -20949,6 +23097,10 @@
             <a:prstDash val="solid"/>
           </a:ln>
         </p:spPr>
+        <p:txBody>
+          <a:bodyPr/>
+          <a:p/>
+        </p:txBody>
       </p:sp>
       <p:sp>
         <p:nvSpPr>
@@ -20974,6 +23126,10 @@
             <a:prstDash val="solid"/>
           </a:ln>
         </p:spPr>
+        <p:txBody>
+          <a:bodyPr/>
+          <a:p/>
+        </p:txBody>
       </p:sp>
       <p:sp>
         <p:nvSpPr>
@@ -21392,7 +23548,7 @@
                 <a:ea typeface="Cambria" pitchFamily="34" charset="-122"/>
                 <a:cs typeface="Cambria" pitchFamily="34" charset="-120"/>
               </a:rPr>
-              <a:t>1,972</a:t>
+              <a:t>1,995</a:t>
             </a:r>
             <a:endParaRPr lang="en-US" sz="4000" dirty="0"/>
           </a:p>
@@ -21431,7 +23587,7 @@
                 <a:ea typeface="Calibri" pitchFamily="34" charset="-122"/>
                 <a:cs typeface="Calibri" pitchFamily="34" charset="-120"/>
               </a:rPr>
-              <a:t>clean rows × 31 columns</a:t>
+              <a:t>clean rows × 34 columns</a:t>
             </a:r>
             <a:endParaRPr lang="en-US" sz="1200" dirty="0"/>
           </a:p>
@@ -21470,7 +23626,7 @@
                 <a:ea typeface="Calibri" pitchFamily="34" charset="-122"/>
                 <a:cs typeface="Calibri" pitchFamily="34" charset="-120"/>
               </a:rPr>
-              <a:t>Why these methods? Median resists the outlier ages; mode is the best single guess for a category; city is imputed within country because it depends on it; rows without a valid price are dropped rather than inventing revenue.</a:t>
+              <a:t>Why these methods? Median resists the outlier ages; mode is the best single guess for a category; city is imputed within country because it depends on it; a missing or wrong price is looked up from the catalogue because every product has one fixed list price.</a:t>
             </a:r>
             <a:endParaRPr lang="en-US" sz="1150" dirty="0"/>
           </a:p>
@@ -21612,6 +23768,10 @@
             <a:prstDash val="solid"/>
           </a:ln>
         </p:spPr>
+        <p:txBody>
+          <a:bodyPr/>
+          <a:p/>
+        </p:txBody>
       </p:sp>
       <p:sp>
         <p:nvSpPr>
@@ -21717,6 +23877,10 @@
             <a:prstDash val="solid"/>
           </a:ln>
         </p:spPr>
+        <p:txBody>
+          <a:bodyPr/>
+          <a:p/>
+        </p:txBody>
       </p:sp>
       <p:sp>
         <p:nvSpPr>
@@ -21822,6 +23986,10 @@
             <a:prstDash val="solid"/>
           </a:ln>
         </p:spPr>
+        <p:txBody>
+          <a:bodyPr/>
+          <a:p/>
+        </p:txBody>
       </p:sp>
       <p:sp>
         <p:nvSpPr>
@@ -21927,6 +24095,10 @@
             <a:prstDash val="solid"/>
           </a:ln>
         </p:spPr>
+        <p:txBody>
+          <a:bodyPr/>
+          <a:p/>
+        </p:txBody>
       </p:sp>
       <p:sp>
         <p:nvSpPr>
@@ -22032,6 +24204,10 @@
             <a:prstDash val="solid"/>
           </a:ln>
         </p:spPr>
+        <p:txBody>
+          <a:bodyPr/>
+          <a:p/>
+        </p:txBody>
       </p:sp>
       <p:sp>
         <p:nvSpPr>
@@ -22137,6 +24313,10 @@
             <a:prstDash val="solid"/>
           </a:ln>
         </p:spPr>
+        <p:txBody>
+          <a:bodyPr/>
+          <a:p/>
+        </p:txBody>
       </p:sp>
       <p:sp>
         <p:nvSpPr>
@@ -22242,6 +24422,10 @@
             <a:prstDash val="solid"/>
           </a:ln>
         </p:spPr>
+        <p:txBody>
+          <a:bodyPr/>
+          <a:p/>
+        </p:txBody>
       </p:sp>
       <p:sp>
         <p:nvSpPr>
@@ -22549,7 +24733,7 @@
                 <a:ea typeface="Cambria" pitchFamily="34" charset="-122"/>
                 <a:cs typeface="Cambria" pitchFamily="34" charset="-120"/>
               </a:rPr>
-              <a:t>Q1 · Electronics is more than half of revenue</a:t>
+              <a:t>Q1 · Electronics is almost half of revenue</a:t>
             </a:r>
             <a:endParaRPr lang="en-US" sz="3200" dirty="0"/>
           </a:p>
@@ -22929,7 +25113,7 @@
                           <a:ea typeface="Calibri" pitchFamily="34" charset="-122"/>
                           <a:cs typeface="Calibri" pitchFamily="34" charset="-120"/>
                         </a:rPr>
-                        <a:t>53.8 %</a:t>
+                        <a:t>47.0 %</a:t>
                       </a:r>
                       <a:endParaRPr lang="en-US" sz="1150" dirty="0">
                         <a:latin typeface="Calibri" charset="0"/>
@@ -22997,7 +25181,7 @@
                           <a:ea typeface="Calibri" pitchFamily="34" charset="-122"/>
                           <a:cs typeface="Calibri" pitchFamily="34" charset="-120"/>
                         </a:rPr>
-                        <a:t>10.1 %</a:t>
+                        <a:t>12.1 %</a:t>
                       </a:r>
                       <a:endParaRPr lang="en-US" sz="1150" dirty="0">
                         <a:latin typeface="Calibri" charset="0"/>
@@ -23135,7 +25319,7 @@
                           <a:ea typeface="Calibri" pitchFamily="34" charset="-122"/>
                           <a:cs typeface="Calibri" pitchFamily="34" charset="-120"/>
                         </a:rPr>
-                        <a:t>14.4 %</a:t>
+                        <a:t>17.6 %</a:t>
                       </a:r>
                       <a:endParaRPr lang="en-US" sz="1150" dirty="0">
                         <a:latin typeface="Calibri" charset="0"/>
@@ -23203,7 +25387,7 @@
                           <a:ea typeface="Calibri" pitchFamily="34" charset="-122"/>
                           <a:cs typeface="Calibri" pitchFamily="34" charset="-120"/>
                         </a:rPr>
-                        <a:t>10.5 %</a:t>
+                        <a:t>9.0 %</a:t>
                       </a:r>
                       <a:endParaRPr lang="en-US" sz="1150" dirty="0">
                         <a:latin typeface="Calibri" charset="0"/>
@@ -23341,7 +25525,7 @@
                           <a:ea typeface="Calibri" pitchFamily="34" charset="-122"/>
                           <a:cs typeface="Calibri" pitchFamily="34" charset="-120"/>
                         </a:rPr>
-                        <a:t>12.3 %</a:t>
+                        <a:t>12.6 %</a:t>
                       </a:r>
                       <a:endParaRPr lang="en-US" sz="1150" dirty="0">
                         <a:latin typeface="Calibri" charset="0"/>
@@ -23409,7 +25593,7 @@
                           <a:ea typeface="Calibri" pitchFamily="34" charset="-122"/>
                           <a:cs typeface="Calibri" pitchFamily="34" charset="-120"/>
                         </a:rPr>
-                        <a:t>13.6 %</a:t>
+                        <a:t>15.7 %</a:t>
                       </a:r>
                       <a:endParaRPr lang="en-US" sz="1150" dirty="0">
                         <a:latin typeface="Calibri" charset="0"/>
@@ -23547,7 +25731,7 @@
                           <a:ea typeface="Calibri" pitchFamily="34" charset="-122"/>
                           <a:cs typeface="Calibri" pitchFamily="34" charset="-120"/>
                         </a:rPr>
-                        <a:t>8.1 %</a:t>
+                        <a:t>8.9 %</a:t>
                       </a:r>
                       <a:endParaRPr lang="en-US" sz="1150" dirty="0">
                         <a:latin typeface="Calibri" charset="0"/>
@@ -23615,7 +25799,7 @@
                           <a:ea typeface="Calibri" pitchFamily="34" charset="-122"/>
                           <a:cs typeface="Calibri" pitchFamily="34" charset="-120"/>
                         </a:rPr>
-                        <a:t>12.3 %</a:t>
+                        <a:t>11.2 %</a:t>
                       </a:r>
                       <a:endParaRPr lang="en-US" sz="1150" dirty="0">
                         <a:latin typeface="Calibri" charset="0"/>
@@ -23753,7 +25937,7 @@
                           <a:ea typeface="Calibri" pitchFamily="34" charset="-122"/>
                           <a:cs typeface="Calibri" pitchFamily="34" charset="-120"/>
                         </a:rPr>
-                        <a:t>5.5 %</a:t>
+                        <a:t>6.6 %</a:t>
                       </a:r>
                       <a:endParaRPr lang="en-US" sz="1150" dirty="0">
                         <a:latin typeface="Calibri" charset="0"/>
@@ -23821,7 +26005,7 @@
                           <a:ea typeface="Calibri" pitchFamily="34" charset="-122"/>
                           <a:cs typeface="Calibri" pitchFamily="34" charset="-120"/>
                         </a:rPr>
-                        <a:t>10.7 %</a:t>
+                        <a:t>8.0 %</a:t>
                       </a:r>
                       <a:endParaRPr lang="en-US" sz="1150" dirty="0">
                         <a:latin typeface="Calibri" charset="0"/>
@@ -24027,7 +26211,7 @@
                           <a:ea typeface="Calibri" pitchFamily="34" charset="-122"/>
                           <a:cs typeface="Calibri" pitchFamily="34" charset="-120"/>
                         </a:rPr>
-                        <a:t>6.2 %</a:t>
+                        <a:t>12.2 %</a:t>
                       </a:r>
                       <a:endParaRPr lang="en-US" sz="1150" dirty="0">
                         <a:latin typeface="Calibri" charset="0"/>
@@ -24165,7 +26349,7 @@
                           <a:ea typeface="Calibri" pitchFamily="34" charset="-122"/>
                           <a:cs typeface="Calibri" pitchFamily="34" charset="-120"/>
                         </a:rPr>
-                        <a:t>2.1 %</a:t>
+                        <a:t>3.5 %</a:t>
                       </a:r>
                       <a:endParaRPr lang="en-US" sz="1150" dirty="0">
                         <a:latin typeface="Calibri" charset="0"/>
@@ -24233,7 +26417,7 @@
                           <a:ea typeface="Calibri" pitchFamily="34" charset="-122"/>
                           <a:cs typeface="Calibri" pitchFamily="34" charset="-120"/>
                         </a:rPr>
-                        <a:t>8.3 %</a:t>
+                        <a:t>7.1 %</a:t>
                       </a:r>
                       <a:endParaRPr lang="en-US" sz="1150" dirty="0">
                         <a:latin typeface="Calibri" charset="0"/>
@@ -24315,6 +26499,10 @@
             <a:prstDash val="solid"/>
           </a:ln>
         </p:spPr>
+        <p:txBody>
+          <a:bodyPr/>
+          <a:p/>
+        </p:txBody>
       </p:sp>
       <p:sp>
         <p:nvSpPr>
@@ -24363,7 +26551,7 @@
                 <a:ea typeface="Calibri" pitchFamily="34" charset="-122"/>
                 <a:cs typeface="Calibri" pitchFamily="34" charset="-120"/>
               </a:rPr>
-              <a:t>Electronics gives 54 % of revenue from 24 % of orders (AOV $304 vs $35–$121). Top three categories ≈ 80 % of revenue (O1). Fashion has the highest return rate — the priority for sizing &amp; product-page fixes.</a:t>
+              <a:t>Electronics gives 47 % of revenue from 24 % of orders (AOV $186 vs $35–$91). Top three categories ≈ 77 % of revenue (O1). Fashion has the highest return rate (15.7 %) — the priority for sizing &amp; product-page fixes.</a:t>
             </a:r>
             <a:endParaRPr lang="en-US" sz="1250" dirty="0"/>
           </a:p>
@@ -24638,7 +26826,7 @@
                 <a:ea typeface="Cambria" pitchFamily="34" charset="-122"/>
                 <a:cs typeface="Cambria" pitchFamily="34" charset="-120"/>
               </a:rPr>
-              <a:t>57 %</a:t>
+              <a:t>59 %</a:t>
             </a:r>
             <a:endParaRPr lang="en-US" sz="4000" dirty="0"/>
           </a:p>
@@ -24794,7 +26982,7 @@
                 <a:ea typeface="Cambria" pitchFamily="34" charset="-122"/>
                 <a:cs typeface="Cambria" pitchFamily="34" charset="-120"/>
               </a:rPr>
-              <a:t>p = 0.60</a:t>
+              <a:t>p = 0.26</a:t>
             </a:r>
             <a:endParaRPr lang="en-US" sz="4000" dirty="0"/>
           </a:p>
@@ -24865,6 +27053,10 @@
             <a:prstDash val="solid"/>
           </a:ln>
         </p:spPr>
+        <p:txBody>
+          <a:bodyPr/>
+          <a:p/>
+        </p:txBody>
       </p:sp>
       <p:sp>
         <p:nvSpPr>
@@ -24913,7 +27105,7 @@
                 <a:ea typeface="Calibri" pitchFamily="34" charset="-122"/>
                 <a:cs typeface="Calibri" pitchFamily="34" charset="-120"/>
               </a:rPr>
-              <a:t>VIPs are 23 % of customers but 40 % of revenue because they order 3× as often as New customers; basket size is the same (t-test p = 0.60). Retention is solid (67 % repeat) yet nearly half the base has gone quiet — the win-back target.</a:t>
+              <a:t>VIPs are 23 % of customers but 40 % of revenue because they order 3× as often as New customers; basket size is no bigger (t-test p = 0.26). Retention is solid (67 % repeat) yet nearly half the base has gone quiet — the win-back target.</a:t>
             </a:r>
             <a:endParaRPr lang="en-US" sz="1250" dirty="0"/>
           </a:p>

</xml_diff>